<commit_message>
docs: finalize aesthetic presentation preserving exact format and simple language
</commit_message>
<xml_diff>
--- a/Smart_Weather_Station_Presentation.pptx
+++ b/Smart_Weather_Station_Presentation.pptx
@@ -3099,14 +3099,57 @@
       <p:grpSpPr/>
       <p:sp>
         <p:nvSpPr>
-          <p:cNvPr id="2" name="TextBox 1"/>
+          <p:cNvPr id="2" name="Rectangle 1"/>
+          <p:cNvSpPr/>
+          <p:nvPr/>
+        </p:nvSpPr>
+        <p:spPr>
+          <a:xfrm>
+            <a:off x="0" y="0"/>
+            <a:ext cx="12191695" cy="91440"/>
+          </a:xfrm>
+          <a:prstGeom prst="rect">
+            <a:avLst/>
+          </a:prstGeom>
+          <a:solidFill>
+            <a:srgbClr val="1A365D"/>
+          </a:solidFill>
+          <a:ln>
+            <a:noFill/>
+          </a:ln>
+        </p:spPr>
+        <p:style>
+          <a:lnRef idx="1">
+            <a:schemeClr val="accent1"/>
+          </a:lnRef>
+          <a:fillRef idx="3">
+            <a:schemeClr val="accent1"/>
+          </a:fillRef>
+          <a:effectRef idx="2">
+            <a:schemeClr val="accent1"/>
+          </a:effectRef>
+          <a:fontRef idx="minor">
+            <a:schemeClr val="lt1"/>
+          </a:fontRef>
+        </p:style>
+        <p:txBody>
+          <a:bodyPr rtlCol="0" anchor="ctr"/>
+          <a:lstStyle/>
+          <a:p>
+            <a:pPr algn="ctr"/>
+          </a:p>
+        </p:txBody>
+      </p:sp>
+      <p:sp>
+        <p:nvSpPr>
+          <p:cNvPr id="3" name="TextBox 2"/>
           <p:cNvSpPr txBox="1"/>
           <p:nvPr/>
         </p:nvSpPr>
         <p:spPr>
           <a:xfrm>
-            <a:off x="914400" y="457200"/>
-            <a:ext cx="10362895" cy="1371600"/>
+            <a:off x="914400" y="548640"/>
+            <a:ext cx="10362895" cy="1463040"/>
           </a:xfrm>
           <a:prstGeom prst="rect">
             <a:avLst/>
@@ -3120,19 +3163,15 @@
           <a:lstStyle/>
           <a:p>
             <a:pPr algn="ctr">
-              <a:defRPr sz="2200" b="1">
-                <a:solidFill>
-                  <a:srgbClr val="000000"/>
-                </a:solidFill>
-                <a:latin typeface="Times New Roman"/>
+              <a:defRPr sz="2400" b="1">
+                <a:solidFill>
+                  <a:srgbClr val="1A365D"/>
+                </a:solidFill>
+                <a:latin typeface="Arial"/>
               </a:defRPr>
             </a:pPr>
             <a:r>
-              <a:t>Galgotias College of Engineering &amp; Technology,</a:t>
-            </a:r>
-            <a:br/>
-            <a:r>
-              <a:t>Greater Noida</a:t>
+              <a:t>Galgotias College of Engineering &amp; Technology, Greater Noida</a:t>
             </a:r>
           </a:p>
           <a:p>
@@ -3140,11 +3179,11 @@
               <a:spcBef>
                 <a:spcPts val="800"/>
               </a:spcBef>
-              <a:defRPr sz="1400" b="1">
-                <a:solidFill>
-                  <a:srgbClr val="000000"/>
-                </a:solidFill>
-                <a:latin typeface="Times New Roman"/>
+              <a:defRPr sz="1300" b="1">
+                <a:solidFill>
+                  <a:srgbClr val="1E293B"/>
+                </a:solidFill>
+                <a:latin typeface="Arial"/>
               </a:defRPr>
             </a:pPr>
             <a:r>
@@ -3155,30 +3194,92 @@
       </p:sp>
       <p:sp>
         <p:nvSpPr>
-          <p:cNvPr id="3" name="TextBox 2"/>
-          <p:cNvSpPr txBox="1"/>
+          <p:cNvPr id="4" name="Rectangle 3"/>
+          <p:cNvSpPr/>
           <p:nvPr/>
         </p:nvSpPr>
         <p:spPr>
           <a:xfrm>
-            <a:off x="914400" y="2560320"/>
-            <a:ext cx="10362895" cy="1371600"/>
+            <a:off x="4114800" y="1920240"/>
+            <a:ext cx="3962095" cy="27432"/>
           </a:xfrm>
           <a:prstGeom prst="rect">
             <a:avLst/>
           </a:prstGeom>
-          <a:noFill/>
-        </p:spPr>
-        <p:txBody>
-          <a:bodyPr wrap="square">
-            <a:spAutoFit/>
-          </a:bodyPr>
+          <a:solidFill>
+            <a:srgbClr val="0D9488"/>
+          </a:solidFill>
+          <a:ln>
+            <a:noFill/>
+          </a:ln>
+        </p:spPr>
+        <p:style>
+          <a:lnRef idx="1">
+            <a:schemeClr val="accent1"/>
+          </a:lnRef>
+          <a:fillRef idx="3">
+            <a:schemeClr val="accent1"/>
+          </a:fillRef>
+          <a:effectRef idx="2">
+            <a:schemeClr val="accent1"/>
+          </a:effectRef>
+          <a:fontRef idx="minor">
+            <a:schemeClr val="lt1"/>
+          </a:fontRef>
+        </p:style>
+        <p:txBody>
+          <a:bodyPr rtlCol="0" anchor="ctr"/>
+          <a:lstStyle/>
+          <a:p>
+            <a:pPr algn="ctr"/>
+          </a:p>
+        </p:txBody>
+      </p:sp>
+      <p:sp>
+        <p:nvSpPr>
+          <p:cNvPr id="5" name="Rounded Rectangle 4"/>
+          <p:cNvSpPr/>
+          <p:nvPr/>
+        </p:nvSpPr>
+        <p:spPr>
+          <a:xfrm>
+            <a:off x="1371600" y="2377440"/>
+            <a:ext cx="9448495" cy="1828800"/>
+          </a:xfrm>
+          <a:prstGeom prst="roundRect">
+            <a:avLst/>
+          </a:prstGeom>
+          <a:solidFill>
+            <a:srgbClr val="F8FAFC"/>
+          </a:solidFill>
+          <a:ln w="19050">
+            <a:solidFill>
+              <a:srgbClr val="E2E8F0"/>
+            </a:solidFill>
+          </a:ln>
+        </p:spPr>
+        <p:style>
+          <a:lnRef idx="1">
+            <a:schemeClr val="accent1"/>
+          </a:lnRef>
+          <a:fillRef idx="3">
+            <a:schemeClr val="accent1"/>
+          </a:fillRef>
+          <a:effectRef idx="2">
+            <a:schemeClr val="accent1"/>
+          </a:effectRef>
+          <a:fontRef idx="minor">
+            <a:schemeClr val="lt1"/>
+          </a:fontRef>
+        </p:style>
+        <p:txBody>
+          <a:bodyPr rtlCol="0" anchor="ctr" wrap="square" tIns="320040"/>
           <a:lstStyle/>
           <a:p>
             <a:pPr algn="ctr">
               <a:defRPr sz="3600" b="1">
                 <a:solidFill>
-                  <a:srgbClr val="000000"/>
+                  <a:srgbClr val="1A365D"/>
                 </a:solidFill>
                 <a:latin typeface="Arial"/>
               </a:defRPr>
@@ -3194,7 +3295,7 @@
               </a:spcBef>
               <a:defRPr sz="1800">
                 <a:solidFill>
-                  <a:srgbClr val="282828"/>
+                  <a:srgbClr val="0D9488"/>
                 </a:solidFill>
                 <a:latin typeface="Arial"/>
               </a:defRPr>
@@ -3207,13 +3308,13 @@
       </p:sp>
       <p:sp>
         <p:nvSpPr>
-          <p:cNvPr id="4" name="TextBox 3"/>
+          <p:cNvPr id="6" name="TextBox 5"/>
           <p:cNvSpPr txBox="1"/>
           <p:nvPr/>
         </p:nvSpPr>
         <p:spPr>
           <a:xfrm>
-            <a:off x="914400" y="4846320"/>
+            <a:off x="1371600" y="4572000"/>
             <a:ext cx="4114800" cy="1645920"/>
           </a:xfrm>
           <a:prstGeom prst="rect">
@@ -3230,7 +3331,7 @@
             <a:pPr>
               <a:defRPr sz="1600" b="1">
                 <a:solidFill>
-                  <a:srgbClr val="B40000"/>
+                  <a:srgbClr val="B91C1C"/>
                 </a:solidFill>
                 <a:latin typeface="Arial"/>
               </a:defRPr>
@@ -3244,9 +3345,9 @@
               <a:spcBef>
                 <a:spcPts val="400"/>
               </a:spcBef>
-              <a:defRPr sz="1500">
-                <a:solidFill>
-                  <a:srgbClr val="000000"/>
+              <a:defRPr sz="1500" b="1">
+                <a:solidFill>
+                  <a:srgbClr val="1E293B"/>
                 </a:solidFill>
                 <a:latin typeface="Arial"/>
               </a:defRPr>
@@ -3255,17 +3356,30 @@
               <a:t>[Mentor Name]</a:t>
             </a:r>
           </a:p>
-        </p:txBody>
-      </p:sp>
-      <p:sp>
-        <p:nvSpPr>
-          <p:cNvPr id="5" name="TextBox 4"/>
+          <a:p>
+            <a:pPr>
+              <a:defRPr sz="1300">
+                <a:solidFill>
+                  <a:srgbClr val="64748B"/>
+                </a:solidFill>
+                <a:latin typeface="Arial"/>
+              </a:defRPr>
+            </a:pPr>
+            <a:r>
+              <a:t>Assistant Professor, Dept of ECE</a:t>
+            </a:r>
+          </a:p>
+        </p:txBody>
+      </p:sp>
+      <p:sp>
+        <p:nvSpPr>
+          <p:cNvPr id="7" name="TextBox 6"/>
           <p:cNvSpPr txBox="1"/>
           <p:nvPr/>
         </p:nvSpPr>
         <p:spPr>
           <a:xfrm>
-            <a:off x="7132320" y="4846320"/>
+            <a:off x="7132320" y="4572000"/>
             <a:ext cx="4114800" cy="1645920"/>
           </a:xfrm>
           <a:prstGeom prst="rect">
@@ -3282,7 +3396,7 @@
             <a:pPr>
               <a:defRPr sz="1600" b="1">
                 <a:solidFill>
-                  <a:srgbClr val="000000"/>
+                  <a:srgbClr val="1A365D"/>
                 </a:solidFill>
                 <a:latin typeface="Arial"/>
               </a:defRPr>
@@ -3294,49 +3408,49 @@
           <a:p>
             <a:pPr>
               <a:spcBef>
-                <a:spcPts val="300"/>
+                <a:spcPts val="400"/>
               </a:spcBef>
-              <a:defRPr sz="1500">
-                <a:solidFill>
-                  <a:srgbClr val="000000"/>
+              <a:defRPr sz="1400">
+                <a:solidFill>
+                  <a:srgbClr val="1E293B"/>
                 </a:solidFill>
                 <a:latin typeface="Arial"/>
               </a:defRPr>
             </a:pPr>
             <a:r>
-              <a:t>1. Prasoon (Roll No)</a:t>
+              <a:t>1. Prasoon (Roll No: ____________)</a:t>
             </a:r>
           </a:p>
           <a:p>
             <a:pPr>
               <a:spcBef>
-                <a:spcPts val="300"/>
+                <a:spcPts val="400"/>
               </a:spcBef>
-              <a:defRPr sz="1500">
-                <a:solidFill>
-                  <a:srgbClr val="000000"/>
+              <a:defRPr sz="1400">
+                <a:solidFill>
+                  <a:srgbClr val="1E293B"/>
                 </a:solidFill>
                 <a:latin typeface="Arial"/>
               </a:defRPr>
             </a:pPr>
             <a:r>
-              <a:t>2. Name (Roll No)</a:t>
+              <a:t>2. Name (Roll No: ____________)</a:t>
             </a:r>
           </a:p>
           <a:p>
             <a:pPr>
               <a:spcBef>
-                <a:spcPts val="300"/>
+                <a:spcPts val="400"/>
               </a:spcBef>
-              <a:defRPr sz="1500">
-                <a:solidFill>
-                  <a:srgbClr val="000000"/>
+              <a:defRPr sz="1400">
+                <a:solidFill>
+                  <a:srgbClr val="1E293B"/>
                 </a:solidFill>
                 <a:latin typeface="Arial"/>
               </a:defRPr>
             </a:pPr>
             <a:r>
-              <a:t>3. Name (Roll No)</a:t>
+              <a:t>3. Name (Roll No: ____________)</a:t>
             </a:r>
           </a:p>
         </p:txBody>
@@ -3361,36 +3475,71 @@
       <p:grpSpPr/>
       <p:sp>
         <p:nvSpPr>
-          <p:cNvPr id="2" name="TextBox 1"/>
-          <p:cNvSpPr txBox="1"/>
+          <p:cNvPr id="2" name="Rounded Rectangle 1"/>
+          <p:cNvSpPr/>
           <p:nvPr/>
         </p:nvSpPr>
         <p:spPr>
           <a:xfrm>
-            <a:off x="914400" y="2377440"/>
-            <a:ext cx="10362895" cy="2011680"/>
-          </a:xfrm>
-          <a:prstGeom prst="rect">
+            <a:off x="2286000" y="1645920"/>
+            <a:ext cx="7619695" cy="3474720"/>
+          </a:xfrm>
+          <a:prstGeom prst="roundRect">
             <a:avLst/>
           </a:prstGeom>
-          <a:noFill/>
-        </p:spPr>
-        <p:txBody>
-          <a:bodyPr wrap="square">
-            <a:spAutoFit/>
-          </a:bodyPr>
+          <a:solidFill>
+            <a:srgbClr val="F8FAFC"/>
+          </a:solidFill>
+          <a:ln w="19050">
+            <a:solidFill>
+              <a:srgbClr val="E2E8F0"/>
+            </a:solidFill>
+          </a:ln>
+        </p:spPr>
+        <p:style>
+          <a:lnRef idx="1">
+            <a:schemeClr val="accent1"/>
+          </a:lnRef>
+          <a:fillRef idx="3">
+            <a:schemeClr val="accent1"/>
+          </a:fillRef>
+          <a:effectRef idx="2">
+            <a:schemeClr val="accent1"/>
+          </a:effectRef>
+          <a:fontRef idx="minor">
+            <a:schemeClr val="lt1"/>
+          </a:fontRef>
+        </p:style>
+        <p:txBody>
+          <a:bodyPr rtlCol="0" anchor="ctr" wrap="square" tIns="731520"/>
           <a:lstStyle/>
           <a:p>
             <a:pPr algn="ctr">
               <a:defRPr sz="5600" b="1">
                 <a:solidFill>
-                  <a:srgbClr val="788CA0"/>
+                  <a:srgbClr val="1A365D"/>
                 </a:solidFill>
                 <a:latin typeface="Arial"/>
               </a:defRPr>
             </a:pPr>
             <a:r>
               <a:t>THANK YOU</a:t>
+            </a:r>
+          </a:p>
+          <a:p>
+            <a:pPr algn="ctr">
+              <a:spcBef>
+                <a:spcPts val="1200"/>
+              </a:spcBef>
+              <a:defRPr sz="2000" b="1">
+                <a:solidFill>
+                  <a:srgbClr val="0D9488"/>
+                </a:solidFill>
+                <a:latin typeface="Arial"/>
+              </a:defRPr>
+            </a:pPr>
+            <a:r>
+              <a:t>Questions &amp; Answers</a:t>
             </a:r>
           </a:p>
         </p:txBody>
@@ -3415,14 +3564,57 @@
       <p:grpSpPr/>
       <p:sp>
         <p:nvSpPr>
-          <p:cNvPr id="2" name="TextBox 1"/>
+          <p:cNvPr id="2" name="Rectangle 1"/>
+          <p:cNvSpPr/>
+          <p:nvPr/>
+        </p:nvSpPr>
+        <p:spPr>
+          <a:xfrm>
+            <a:off x="0" y="0"/>
+            <a:ext cx="12191695" cy="73152"/>
+          </a:xfrm>
+          <a:prstGeom prst="rect">
+            <a:avLst/>
+          </a:prstGeom>
+          <a:solidFill>
+            <a:srgbClr val="1A365D"/>
+          </a:solidFill>
+          <a:ln>
+            <a:noFill/>
+          </a:ln>
+        </p:spPr>
+        <p:style>
+          <a:lnRef idx="1">
+            <a:schemeClr val="accent1"/>
+          </a:lnRef>
+          <a:fillRef idx="3">
+            <a:schemeClr val="accent1"/>
+          </a:fillRef>
+          <a:effectRef idx="2">
+            <a:schemeClr val="accent1"/>
+          </a:effectRef>
+          <a:fontRef idx="minor">
+            <a:schemeClr val="lt1"/>
+          </a:fontRef>
+        </p:style>
+        <p:txBody>
+          <a:bodyPr rtlCol="0" anchor="ctr"/>
+          <a:lstStyle/>
+          <a:p>
+            <a:pPr algn="ctr"/>
+          </a:p>
+        </p:txBody>
+      </p:sp>
+      <p:sp>
+        <p:nvSpPr>
+          <p:cNvPr id="3" name="TextBox 2"/>
           <p:cNvSpPr txBox="1"/>
           <p:nvPr/>
         </p:nvSpPr>
         <p:spPr>
           <a:xfrm>
-            <a:off x="914400" y="548640"/>
-            <a:ext cx="10362895" cy="914400"/>
+            <a:off x="914400" y="502920"/>
+            <a:ext cx="10362895" cy="777240"/>
           </a:xfrm>
           <a:prstGeom prst="rect">
             <a:avLst/>
@@ -3438,7 +3630,7 @@
             <a:pPr algn="ctr">
               <a:defRPr sz="2800" b="1">
                 <a:solidFill>
-                  <a:srgbClr val="000000"/>
+                  <a:srgbClr val="1A365D"/>
                 </a:solidFill>
                 <a:latin typeface="Arial"/>
               </a:defRPr>
@@ -3451,119 +3643,469 @@
       </p:sp>
       <p:sp>
         <p:nvSpPr>
-          <p:cNvPr id="3" name="TextBox 2"/>
-          <p:cNvSpPr txBox="1"/>
+          <p:cNvPr id="4" name="Rectangle 3"/>
+          <p:cNvSpPr/>
           <p:nvPr/>
         </p:nvSpPr>
         <p:spPr>
           <a:xfrm>
-            <a:off x="1371600" y="1828800"/>
-            <a:ext cx="9144000" cy="4389120"/>
+            <a:off x="5180990" y="1325880"/>
+            <a:ext cx="1828800" cy="36576"/>
           </a:xfrm>
           <a:prstGeom prst="rect">
             <a:avLst/>
           </a:prstGeom>
-          <a:noFill/>
-        </p:spPr>
-        <p:txBody>
-          <a:bodyPr wrap="square">
-            <a:spAutoFit/>
-          </a:bodyPr>
-          <a:lstStyle/>
+          <a:solidFill>
+            <a:srgbClr val="0D9488"/>
+          </a:solidFill>
+          <a:ln>
+            <a:noFill/>
+          </a:ln>
+        </p:spPr>
+        <p:style>
+          <a:lnRef idx="1">
+            <a:schemeClr val="accent1"/>
+          </a:lnRef>
+          <a:fillRef idx="3">
+            <a:schemeClr val="accent1"/>
+          </a:fillRef>
+          <a:effectRef idx="2">
+            <a:schemeClr val="accent1"/>
+          </a:effectRef>
+          <a:fontRef idx="minor">
+            <a:schemeClr val="lt1"/>
+          </a:fontRef>
+        </p:style>
+        <p:txBody>
+          <a:bodyPr rtlCol="0" anchor="ctr"/>
+          <a:lstStyle/>
+          <a:p>
+            <a:pPr algn="ctr"/>
+          </a:p>
+        </p:txBody>
+      </p:sp>
+      <p:sp>
+        <p:nvSpPr>
+          <p:cNvPr id="5" name="Rounded Rectangle 4"/>
+          <p:cNvSpPr/>
+          <p:nvPr/>
+        </p:nvSpPr>
+        <p:spPr>
+          <a:xfrm>
+            <a:off x="1280160" y="1737360"/>
+            <a:ext cx="4663440" cy="1188720"/>
+          </a:xfrm>
+          <a:prstGeom prst="roundRect">
+            <a:avLst/>
+          </a:prstGeom>
+          <a:solidFill>
+            <a:srgbClr val="F8FAFC"/>
+          </a:solidFill>
+          <a:ln w="12700">
+            <a:solidFill>
+              <a:srgbClr val="E2E8F0"/>
+            </a:solidFill>
+          </a:ln>
+        </p:spPr>
+        <p:style>
+          <a:lnRef idx="1">
+            <a:schemeClr val="accent1"/>
+          </a:lnRef>
+          <a:fillRef idx="3">
+            <a:schemeClr val="accent1"/>
+          </a:fillRef>
+          <a:effectRef idx="2">
+            <a:schemeClr val="accent1"/>
+          </a:effectRef>
+          <a:fontRef idx="minor">
+            <a:schemeClr val="lt1"/>
+          </a:fontRef>
+        </p:style>
+        <p:txBody>
+          <a:bodyPr rtlCol="0" anchor="ctr" wrap="square" lIns="274320" tIns="182880"/>
+          <a:lstStyle/>
+          <a:p>
+            <a:pPr algn="ctr">
+              <a:defRPr sz="1800" b="1">
+                <a:solidFill>
+                  <a:srgbClr val="1A365D"/>
+                </a:solidFill>
+                <a:latin typeface="Arial"/>
+              </a:defRPr>
+            </a:pPr>
+            <a:r>
+              <a:t>❖  Introduction</a:t>
+            </a:r>
+          </a:p>
           <a:p>
             <a:pPr>
               <a:spcBef>
-                <a:spcPts val="2200"/>
+                <a:spcPts val="400"/>
               </a:spcBef>
-              <a:defRPr sz="2000" b="1">
-                <a:solidFill>
-                  <a:srgbClr val="000000"/>
+              <a:defRPr sz="1200">
+                <a:solidFill>
+                  <a:srgbClr val="64748B"/>
                 </a:solidFill>
                 <a:latin typeface="Arial"/>
               </a:defRPr>
             </a:pPr>
             <a:r>
-              <a:t>❖  Introduction</a:t>
+              <a:t>Why weather monitoring matters and how IoT helps.</a:t>
+            </a:r>
+          </a:p>
+        </p:txBody>
+      </p:sp>
+      <p:sp>
+        <p:nvSpPr>
+          <p:cNvPr id="6" name="Rounded Rectangle 5"/>
+          <p:cNvSpPr/>
+          <p:nvPr/>
+        </p:nvSpPr>
+        <p:spPr>
+          <a:xfrm>
+            <a:off x="6217920" y="1737360"/>
+            <a:ext cx="4663440" cy="1188720"/>
+          </a:xfrm>
+          <a:prstGeom prst="roundRect">
+            <a:avLst/>
+          </a:prstGeom>
+          <a:solidFill>
+            <a:srgbClr val="F8FAFC"/>
+          </a:solidFill>
+          <a:ln w="12700">
+            <a:solidFill>
+              <a:srgbClr val="E2E8F0"/>
+            </a:solidFill>
+          </a:ln>
+        </p:spPr>
+        <p:style>
+          <a:lnRef idx="1">
+            <a:schemeClr val="accent1"/>
+          </a:lnRef>
+          <a:fillRef idx="3">
+            <a:schemeClr val="accent1"/>
+          </a:fillRef>
+          <a:effectRef idx="2">
+            <a:schemeClr val="accent1"/>
+          </a:effectRef>
+          <a:fontRef idx="minor">
+            <a:schemeClr val="lt1"/>
+          </a:fontRef>
+        </p:style>
+        <p:txBody>
+          <a:bodyPr rtlCol="0" anchor="ctr" wrap="square" lIns="274320" tIns="182880"/>
+          <a:lstStyle/>
+          <a:p>
+            <a:pPr algn="ctr">
+              <a:defRPr sz="1800" b="1">
+                <a:solidFill>
+                  <a:srgbClr val="1A365D"/>
+                </a:solidFill>
+                <a:latin typeface="Arial"/>
+              </a:defRPr>
+            </a:pPr>
+            <a:r>
+              <a:t>❖  Motivation</a:t>
             </a:r>
           </a:p>
           <a:p>
             <a:pPr>
               <a:spcBef>
-                <a:spcPts val="2200"/>
+                <a:spcPts val="400"/>
               </a:spcBef>
-              <a:defRPr sz="2000" b="1">
-                <a:solidFill>
-                  <a:srgbClr val="000000"/>
+              <a:defRPr sz="1200">
+                <a:solidFill>
+                  <a:srgbClr val="64748B"/>
                 </a:solidFill>
                 <a:latin typeface="Arial"/>
               </a:defRPr>
             </a:pPr>
             <a:r>
-              <a:t>❖  Motivation</a:t>
+              <a:t>Problems with old stations and the need for local data.</a:t>
+            </a:r>
+          </a:p>
+        </p:txBody>
+      </p:sp>
+      <p:sp>
+        <p:nvSpPr>
+          <p:cNvPr id="7" name="Rounded Rectangle 6"/>
+          <p:cNvSpPr/>
+          <p:nvPr/>
+        </p:nvSpPr>
+        <p:spPr>
+          <a:xfrm>
+            <a:off x="1280160" y="3154680"/>
+            <a:ext cx="4663440" cy="1188720"/>
+          </a:xfrm>
+          <a:prstGeom prst="roundRect">
+            <a:avLst/>
+          </a:prstGeom>
+          <a:solidFill>
+            <a:srgbClr val="F8FAFC"/>
+          </a:solidFill>
+          <a:ln w="12700">
+            <a:solidFill>
+              <a:srgbClr val="E2E8F0"/>
+            </a:solidFill>
+          </a:ln>
+        </p:spPr>
+        <p:style>
+          <a:lnRef idx="1">
+            <a:schemeClr val="accent1"/>
+          </a:lnRef>
+          <a:fillRef idx="3">
+            <a:schemeClr val="accent1"/>
+          </a:fillRef>
+          <a:effectRef idx="2">
+            <a:schemeClr val="accent1"/>
+          </a:effectRef>
+          <a:fontRef idx="minor">
+            <a:schemeClr val="lt1"/>
+          </a:fontRef>
+        </p:style>
+        <p:txBody>
+          <a:bodyPr rtlCol="0" anchor="ctr" wrap="square" lIns="274320" tIns="182880"/>
+          <a:lstStyle/>
+          <a:p>
+            <a:pPr algn="ctr">
+              <a:defRPr sz="1800" b="1">
+                <a:solidFill>
+                  <a:srgbClr val="1A365D"/>
+                </a:solidFill>
+                <a:latin typeface="Arial"/>
+              </a:defRPr>
+            </a:pPr>
+            <a:r>
+              <a:t>❖  Objectives</a:t>
             </a:r>
           </a:p>
           <a:p>
             <a:pPr>
               <a:spcBef>
-                <a:spcPts val="2200"/>
+                <a:spcPts val="400"/>
               </a:spcBef>
-              <a:defRPr sz="2000" b="1">
-                <a:solidFill>
-                  <a:srgbClr val="000000"/>
+              <a:defRPr sz="1200">
+                <a:solidFill>
+                  <a:srgbClr val="64748B"/>
                 </a:solidFill>
                 <a:latin typeface="Arial"/>
               </a:defRPr>
             </a:pPr>
             <a:r>
-              <a:t>❖  Objectives</a:t>
+              <a:t>What we wanted to build and achieve in this project.</a:t>
+            </a:r>
+          </a:p>
+        </p:txBody>
+      </p:sp>
+      <p:sp>
+        <p:nvSpPr>
+          <p:cNvPr id="8" name="Rounded Rectangle 7"/>
+          <p:cNvSpPr/>
+          <p:nvPr/>
+        </p:nvSpPr>
+        <p:spPr>
+          <a:xfrm>
+            <a:off x="6217920" y="3154680"/>
+            <a:ext cx="4663440" cy="1188720"/>
+          </a:xfrm>
+          <a:prstGeom prst="roundRect">
+            <a:avLst/>
+          </a:prstGeom>
+          <a:solidFill>
+            <a:srgbClr val="F8FAFC"/>
+          </a:solidFill>
+          <a:ln w="12700">
+            <a:solidFill>
+              <a:srgbClr val="E2E8F0"/>
+            </a:solidFill>
+          </a:ln>
+        </p:spPr>
+        <p:style>
+          <a:lnRef idx="1">
+            <a:schemeClr val="accent1"/>
+          </a:lnRef>
+          <a:fillRef idx="3">
+            <a:schemeClr val="accent1"/>
+          </a:fillRef>
+          <a:effectRef idx="2">
+            <a:schemeClr val="accent1"/>
+          </a:effectRef>
+          <a:fontRef idx="minor">
+            <a:schemeClr val="lt1"/>
+          </a:fontRef>
+        </p:style>
+        <p:txBody>
+          <a:bodyPr rtlCol="0" anchor="ctr" wrap="square" lIns="274320" tIns="182880"/>
+          <a:lstStyle/>
+          <a:p>
+            <a:pPr algn="ctr">
+              <a:defRPr sz="1800" b="1">
+                <a:solidFill>
+                  <a:srgbClr val="1A365D"/>
+                </a:solidFill>
+                <a:latin typeface="Arial"/>
+              </a:defRPr>
+            </a:pPr>
+            <a:r>
+              <a:t>❖  Description</a:t>
             </a:r>
           </a:p>
           <a:p>
             <a:pPr>
               <a:spcBef>
-                <a:spcPts val="2200"/>
+                <a:spcPts val="400"/>
               </a:spcBef>
-              <a:defRPr sz="2000" b="1">
-                <a:solidFill>
-                  <a:srgbClr val="000000"/>
+              <a:defRPr sz="1200">
+                <a:solidFill>
+                  <a:srgbClr val="64748B"/>
                 </a:solidFill>
                 <a:latin typeface="Arial"/>
               </a:defRPr>
             </a:pPr>
             <a:r>
-              <a:t>❖  Description</a:t>
+              <a:t>Hardware parts, circuit connections, and working flow.</a:t>
+            </a:r>
+          </a:p>
+        </p:txBody>
+      </p:sp>
+      <p:sp>
+        <p:nvSpPr>
+          <p:cNvPr id="9" name="Rounded Rectangle 8"/>
+          <p:cNvSpPr/>
+          <p:nvPr/>
+        </p:nvSpPr>
+        <p:spPr>
+          <a:xfrm>
+            <a:off x="1280160" y="4572000"/>
+            <a:ext cx="4663440" cy="1188720"/>
+          </a:xfrm>
+          <a:prstGeom prst="roundRect">
+            <a:avLst/>
+          </a:prstGeom>
+          <a:solidFill>
+            <a:srgbClr val="F8FAFC"/>
+          </a:solidFill>
+          <a:ln w="12700">
+            <a:solidFill>
+              <a:srgbClr val="E2E8F0"/>
+            </a:solidFill>
+          </a:ln>
+        </p:spPr>
+        <p:style>
+          <a:lnRef idx="1">
+            <a:schemeClr val="accent1"/>
+          </a:lnRef>
+          <a:fillRef idx="3">
+            <a:schemeClr val="accent1"/>
+          </a:fillRef>
+          <a:effectRef idx="2">
+            <a:schemeClr val="accent1"/>
+          </a:effectRef>
+          <a:fontRef idx="minor">
+            <a:schemeClr val="lt1"/>
+          </a:fontRef>
+        </p:style>
+        <p:txBody>
+          <a:bodyPr rtlCol="0" anchor="ctr" wrap="square" lIns="274320" tIns="182880"/>
+          <a:lstStyle/>
+          <a:p>
+            <a:pPr algn="ctr">
+              <a:defRPr sz="1800" b="1">
+                <a:solidFill>
+                  <a:srgbClr val="1A365D"/>
+                </a:solidFill>
+                <a:latin typeface="Arial"/>
+              </a:defRPr>
+            </a:pPr>
+            <a:r>
+              <a:t>❖  Conclusion</a:t>
             </a:r>
           </a:p>
           <a:p>
             <a:pPr>
               <a:spcBef>
-                <a:spcPts val="2200"/>
+                <a:spcPts val="400"/>
               </a:spcBef>
-              <a:defRPr sz="2000" b="1">
-                <a:solidFill>
-                  <a:srgbClr val="000000"/>
+              <a:defRPr sz="1200">
+                <a:solidFill>
+                  <a:srgbClr val="64748B"/>
                 </a:solidFill>
                 <a:latin typeface="Arial"/>
               </a:defRPr>
             </a:pPr>
             <a:r>
-              <a:t>❖  Conclusion</a:t>
+              <a:t>What we achieved and ideas for future improvements.</a:t>
+            </a:r>
+          </a:p>
+        </p:txBody>
+      </p:sp>
+      <p:sp>
+        <p:nvSpPr>
+          <p:cNvPr id="10" name="Rounded Rectangle 9"/>
+          <p:cNvSpPr/>
+          <p:nvPr/>
+        </p:nvSpPr>
+        <p:spPr>
+          <a:xfrm>
+            <a:off x="6217920" y="4572000"/>
+            <a:ext cx="4663440" cy="1188720"/>
+          </a:xfrm>
+          <a:prstGeom prst="roundRect">
+            <a:avLst/>
+          </a:prstGeom>
+          <a:solidFill>
+            <a:srgbClr val="F8FAFC"/>
+          </a:solidFill>
+          <a:ln w="12700">
+            <a:solidFill>
+              <a:srgbClr val="E2E8F0"/>
+            </a:solidFill>
+          </a:ln>
+        </p:spPr>
+        <p:style>
+          <a:lnRef idx="1">
+            <a:schemeClr val="accent1"/>
+          </a:lnRef>
+          <a:fillRef idx="3">
+            <a:schemeClr val="accent1"/>
+          </a:fillRef>
+          <a:effectRef idx="2">
+            <a:schemeClr val="accent1"/>
+          </a:effectRef>
+          <a:fontRef idx="minor">
+            <a:schemeClr val="lt1"/>
+          </a:fontRef>
+        </p:style>
+        <p:txBody>
+          <a:bodyPr rtlCol="0" anchor="ctr" wrap="square" lIns="274320" tIns="182880"/>
+          <a:lstStyle/>
+          <a:p>
+            <a:pPr algn="ctr">
+              <a:defRPr sz="1800" b="1">
+                <a:solidFill>
+                  <a:srgbClr val="1A365D"/>
+                </a:solidFill>
+                <a:latin typeface="Arial"/>
+              </a:defRPr>
+            </a:pPr>
+            <a:r>
+              <a:t>❖  References</a:t>
             </a:r>
           </a:p>
           <a:p>
             <a:pPr>
               <a:spcBef>
-                <a:spcPts val="2200"/>
+                <a:spcPts val="400"/>
               </a:spcBef>
-              <a:defRPr sz="2000" b="1">
-                <a:solidFill>
-                  <a:srgbClr val="000000"/>
+              <a:defRPr sz="1200">
+                <a:solidFill>
+                  <a:srgbClr val="64748B"/>
                 </a:solidFill>
                 <a:latin typeface="Arial"/>
               </a:defRPr>
             </a:pPr>
             <a:r>
-              <a:t>❖  References</a:t>
+              <a:t>Research papers, books, and component datasheets.</a:t>
             </a:r>
           </a:p>
         </p:txBody>
@@ -3588,14 +4130,57 @@
       <p:grpSpPr/>
       <p:sp>
         <p:nvSpPr>
-          <p:cNvPr id="2" name="TextBox 1"/>
+          <p:cNvPr id="2" name="Rectangle 1"/>
+          <p:cNvSpPr/>
+          <p:nvPr/>
+        </p:nvSpPr>
+        <p:spPr>
+          <a:xfrm>
+            <a:off x="0" y="0"/>
+            <a:ext cx="12191695" cy="73152"/>
+          </a:xfrm>
+          <a:prstGeom prst="rect">
+            <a:avLst/>
+          </a:prstGeom>
+          <a:solidFill>
+            <a:srgbClr val="1A365D"/>
+          </a:solidFill>
+          <a:ln>
+            <a:noFill/>
+          </a:ln>
+        </p:spPr>
+        <p:style>
+          <a:lnRef idx="1">
+            <a:schemeClr val="accent1"/>
+          </a:lnRef>
+          <a:fillRef idx="3">
+            <a:schemeClr val="accent1"/>
+          </a:fillRef>
+          <a:effectRef idx="2">
+            <a:schemeClr val="accent1"/>
+          </a:effectRef>
+          <a:fontRef idx="minor">
+            <a:schemeClr val="lt1"/>
+          </a:fontRef>
+        </p:style>
+        <p:txBody>
+          <a:bodyPr rtlCol="0" anchor="ctr"/>
+          <a:lstStyle/>
+          <a:p>
+            <a:pPr algn="ctr"/>
+          </a:p>
+        </p:txBody>
+      </p:sp>
+      <p:sp>
+        <p:nvSpPr>
+          <p:cNvPr id="3" name="TextBox 2"/>
           <p:cNvSpPr txBox="1"/>
           <p:nvPr/>
         </p:nvSpPr>
         <p:spPr>
           <a:xfrm>
-            <a:off x="914400" y="548640"/>
-            <a:ext cx="10362895" cy="914400"/>
+            <a:off x="914400" y="502920"/>
+            <a:ext cx="10362895" cy="777240"/>
           </a:xfrm>
           <a:prstGeom prst="rect">
             <a:avLst/>
@@ -3611,7 +4196,7 @@
             <a:pPr algn="ctr">
               <a:defRPr sz="2800" b="1">
                 <a:solidFill>
-                  <a:srgbClr val="000000"/>
+                  <a:srgbClr val="1A365D"/>
                 </a:solidFill>
                 <a:latin typeface="Arial"/>
               </a:defRPr>
@@ -3624,103 +4209,318 @@
       </p:sp>
       <p:sp>
         <p:nvSpPr>
-          <p:cNvPr id="3" name="TextBox 2"/>
-          <p:cNvSpPr txBox="1"/>
+          <p:cNvPr id="4" name="Rectangle 3"/>
+          <p:cNvSpPr/>
           <p:nvPr/>
         </p:nvSpPr>
         <p:spPr>
           <a:xfrm>
-            <a:off x="1097280" y="1645920"/>
-            <a:ext cx="10058400" cy="4754880"/>
+            <a:off x="5180990" y="1325880"/>
+            <a:ext cx="1828800" cy="36576"/>
           </a:xfrm>
           <a:prstGeom prst="rect">
             <a:avLst/>
           </a:prstGeom>
-          <a:noFill/>
-        </p:spPr>
-        <p:txBody>
-          <a:bodyPr wrap="square">
-            <a:spAutoFit/>
-          </a:bodyPr>
-          <a:lstStyle/>
-          <a:p>
-            <a:pPr>
-              <a:spcBef>
-                <a:spcPts val="2000"/>
-              </a:spcBef>
-              <a:defRPr sz="1700">
-                <a:solidFill>
-                  <a:srgbClr val="000000"/>
+          <a:solidFill>
+            <a:srgbClr val="0D9488"/>
+          </a:solidFill>
+          <a:ln>
+            <a:noFill/>
+          </a:ln>
+        </p:spPr>
+        <p:style>
+          <a:lnRef idx="1">
+            <a:schemeClr val="accent1"/>
+          </a:lnRef>
+          <a:fillRef idx="3">
+            <a:schemeClr val="accent1"/>
+          </a:fillRef>
+          <a:effectRef idx="2">
+            <a:schemeClr val="accent1"/>
+          </a:effectRef>
+          <a:fontRef idx="minor">
+            <a:schemeClr val="lt1"/>
+          </a:fontRef>
+        </p:style>
+        <p:txBody>
+          <a:bodyPr rtlCol="0" anchor="ctr"/>
+          <a:lstStyle/>
+          <a:p>
+            <a:pPr algn="ctr"/>
+          </a:p>
+        </p:txBody>
+      </p:sp>
+      <p:sp>
+        <p:nvSpPr>
+          <p:cNvPr id="5" name="Rounded Rectangle 4"/>
+          <p:cNvSpPr/>
+          <p:nvPr/>
+        </p:nvSpPr>
+        <p:spPr>
+          <a:xfrm>
+            <a:off x="1097280" y="1691640"/>
+            <a:ext cx="9997135" cy="777240"/>
+          </a:xfrm>
+          <a:prstGeom prst="roundRect">
+            <a:avLst/>
+          </a:prstGeom>
+          <a:solidFill>
+            <a:srgbClr val="F8FAFC"/>
+          </a:solidFill>
+          <a:ln w="12700">
+            <a:solidFill>
+              <a:srgbClr val="E2E8F0"/>
+            </a:solidFill>
+          </a:ln>
+        </p:spPr>
+        <p:style>
+          <a:lnRef idx="1">
+            <a:schemeClr val="accent1"/>
+          </a:lnRef>
+          <a:fillRef idx="3">
+            <a:schemeClr val="accent1"/>
+          </a:fillRef>
+          <a:effectRef idx="2">
+            <a:schemeClr val="accent1"/>
+          </a:effectRef>
+          <a:fontRef idx="minor">
+            <a:schemeClr val="lt1"/>
+          </a:fontRef>
+        </p:style>
+        <p:txBody>
+          <a:bodyPr rtlCol="0" anchor="ctr" wrap="square" lIns="274320" tIns="164592"/>
+          <a:lstStyle/>
+          <a:p>
+            <a:pPr algn="ctr">
+              <a:defRPr sz="1500">
+                <a:solidFill>
+                  <a:srgbClr val="1E293B"/>
                 </a:solidFill>
                 <a:latin typeface="Arial"/>
               </a:defRPr>
             </a:pPr>
             <a:r>
-              <a:t>•  Weather conditions like temperature and humidity affect our daily lives, health, and work.</a:t>
-            </a:r>
-          </a:p>
-          <a:p>
-            <a:pPr>
-              <a:spcBef>
-                <a:spcPts val="2000"/>
-              </a:spcBef>
-              <a:defRPr sz="1700">
-                <a:solidFill>
-                  <a:srgbClr val="000000"/>
+              <a:t>•   Weather conditions like temperature and humidity affect our daily lives, health, and work.</a:t>
+            </a:r>
+          </a:p>
+        </p:txBody>
+      </p:sp>
+      <p:sp>
+        <p:nvSpPr>
+          <p:cNvPr id="6" name="Rounded Rectangle 5"/>
+          <p:cNvSpPr/>
+          <p:nvPr/>
+        </p:nvSpPr>
+        <p:spPr>
+          <a:xfrm>
+            <a:off x="1097280" y="2606040"/>
+            <a:ext cx="9997135" cy="777240"/>
+          </a:xfrm>
+          <a:prstGeom prst="roundRect">
+            <a:avLst/>
+          </a:prstGeom>
+          <a:solidFill>
+            <a:srgbClr val="F8FAFC"/>
+          </a:solidFill>
+          <a:ln w="12700">
+            <a:solidFill>
+              <a:srgbClr val="E2E8F0"/>
+            </a:solidFill>
+          </a:ln>
+        </p:spPr>
+        <p:style>
+          <a:lnRef idx="1">
+            <a:schemeClr val="accent1"/>
+          </a:lnRef>
+          <a:fillRef idx="3">
+            <a:schemeClr val="accent1"/>
+          </a:fillRef>
+          <a:effectRef idx="2">
+            <a:schemeClr val="accent1"/>
+          </a:effectRef>
+          <a:fontRef idx="minor">
+            <a:schemeClr val="lt1"/>
+          </a:fontRef>
+        </p:style>
+        <p:txBody>
+          <a:bodyPr rtlCol="0" anchor="ctr" wrap="square" lIns="274320" tIns="164592"/>
+          <a:lstStyle/>
+          <a:p>
+            <a:pPr algn="ctr">
+              <a:defRPr sz="1500">
+                <a:solidFill>
+                  <a:srgbClr val="1E293B"/>
                 </a:solidFill>
                 <a:latin typeface="Arial"/>
               </a:defRPr>
             </a:pPr>
             <a:r>
-              <a:t>•  Traditional weather stations are big, expensive, and cannot be checked easily from home.</a:t>
-            </a:r>
-          </a:p>
-          <a:p>
-            <a:pPr>
-              <a:spcBef>
-                <a:spcPts val="2000"/>
-              </a:spcBef>
-              <a:defRPr sz="1700">
-                <a:solidFill>
-                  <a:srgbClr val="000000"/>
+              <a:t>•   Traditional weather stations are big, expensive, and cannot be checked easily from home.</a:t>
+            </a:r>
+          </a:p>
+        </p:txBody>
+      </p:sp>
+      <p:sp>
+        <p:nvSpPr>
+          <p:cNvPr id="7" name="Rounded Rectangle 6"/>
+          <p:cNvSpPr/>
+          <p:nvPr/>
+        </p:nvSpPr>
+        <p:spPr>
+          <a:xfrm>
+            <a:off x="1097280" y="3520440"/>
+            <a:ext cx="9997135" cy="777240"/>
+          </a:xfrm>
+          <a:prstGeom prst="roundRect">
+            <a:avLst/>
+          </a:prstGeom>
+          <a:solidFill>
+            <a:srgbClr val="F8FAFC"/>
+          </a:solidFill>
+          <a:ln w="12700">
+            <a:solidFill>
+              <a:srgbClr val="E2E8F0"/>
+            </a:solidFill>
+          </a:ln>
+        </p:spPr>
+        <p:style>
+          <a:lnRef idx="1">
+            <a:schemeClr val="accent1"/>
+          </a:lnRef>
+          <a:fillRef idx="3">
+            <a:schemeClr val="accent1"/>
+          </a:fillRef>
+          <a:effectRef idx="2">
+            <a:schemeClr val="accent1"/>
+          </a:effectRef>
+          <a:fontRef idx="minor">
+            <a:schemeClr val="lt1"/>
+          </a:fontRef>
+        </p:style>
+        <p:txBody>
+          <a:bodyPr rtlCol="0" anchor="ctr" wrap="square" lIns="274320" tIns="164592"/>
+          <a:lstStyle/>
+          <a:p>
+            <a:pPr algn="ctr">
+              <a:defRPr sz="1500">
+                <a:solidFill>
+                  <a:srgbClr val="1E293B"/>
                 </a:solidFill>
                 <a:latin typeface="Arial"/>
               </a:defRPr>
             </a:pPr>
             <a:r>
-              <a:t>•  Internet of Things (IoT) allows us to connect small sensors to the internet to collect weather data automatically.</a:t>
-            </a:r>
-          </a:p>
-          <a:p>
-            <a:pPr>
-              <a:spcBef>
-                <a:spcPts val="2000"/>
-              </a:spcBef>
-              <a:defRPr sz="1700">
-                <a:solidFill>
-                  <a:srgbClr val="000000"/>
+              <a:t>•   Internet of Things (IoT) allows us to connect small sensors to the internet to collect weather data automatically.</a:t>
+            </a:r>
+          </a:p>
+        </p:txBody>
+      </p:sp>
+      <p:sp>
+        <p:nvSpPr>
+          <p:cNvPr id="8" name="Rounded Rectangle 7"/>
+          <p:cNvSpPr/>
+          <p:nvPr/>
+        </p:nvSpPr>
+        <p:spPr>
+          <a:xfrm>
+            <a:off x="1097280" y="4434840"/>
+            <a:ext cx="9997135" cy="777240"/>
+          </a:xfrm>
+          <a:prstGeom prst="roundRect">
+            <a:avLst/>
+          </a:prstGeom>
+          <a:solidFill>
+            <a:srgbClr val="F8FAFC"/>
+          </a:solidFill>
+          <a:ln w="12700">
+            <a:solidFill>
+              <a:srgbClr val="E2E8F0"/>
+            </a:solidFill>
+          </a:ln>
+        </p:spPr>
+        <p:style>
+          <a:lnRef idx="1">
+            <a:schemeClr val="accent1"/>
+          </a:lnRef>
+          <a:fillRef idx="3">
+            <a:schemeClr val="accent1"/>
+          </a:fillRef>
+          <a:effectRef idx="2">
+            <a:schemeClr val="accent1"/>
+          </a:effectRef>
+          <a:fontRef idx="minor">
+            <a:schemeClr val="lt1"/>
+          </a:fontRef>
+        </p:style>
+        <p:txBody>
+          <a:bodyPr rtlCol="0" anchor="ctr" wrap="square" lIns="274320" tIns="164592"/>
+          <a:lstStyle/>
+          <a:p>
+            <a:pPr algn="ctr">
+              <a:defRPr sz="1500">
+                <a:solidFill>
+                  <a:srgbClr val="1E293B"/>
                 </a:solidFill>
                 <a:latin typeface="Arial"/>
               </a:defRPr>
             </a:pPr>
             <a:r>
-              <a:t>•  In this project, we built a low-cost smart weather station using an ESP32 board and a DHT22 sensor.</a:t>
-            </a:r>
-          </a:p>
-          <a:p>
-            <a:pPr>
-              <a:spcBef>
-                <a:spcPts val="2000"/>
-              </a:spcBef>
-              <a:defRPr sz="1700">
-                <a:solidFill>
-                  <a:srgbClr val="000000"/>
+              <a:t>•   In this project, we built a low-cost smart weather station using an ESP32 board and a DHT22 sensor.</a:t>
+            </a:r>
+          </a:p>
+        </p:txBody>
+      </p:sp>
+      <p:sp>
+        <p:nvSpPr>
+          <p:cNvPr id="9" name="Rounded Rectangle 8"/>
+          <p:cNvSpPr/>
+          <p:nvPr/>
+        </p:nvSpPr>
+        <p:spPr>
+          <a:xfrm>
+            <a:off x="1097280" y="5349240"/>
+            <a:ext cx="9997135" cy="777240"/>
+          </a:xfrm>
+          <a:prstGeom prst="roundRect">
+            <a:avLst/>
+          </a:prstGeom>
+          <a:solidFill>
+            <a:srgbClr val="F8FAFC"/>
+          </a:solidFill>
+          <a:ln w="12700">
+            <a:solidFill>
+              <a:srgbClr val="E2E8F0"/>
+            </a:solidFill>
+          </a:ln>
+        </p:spPr>
+        <p:style>
+          <a:lnRef idx="1">
+            <a:schemeClr val="accent1"/>
+          </a:lnRef>
+          <a:fillRef idx="3">
+            <a:schemeClr val="accent1"/>
+          </a:fillRef>
+          <a:effectRef idx="2">
+            <a:schemeClr val="accent1"/>
+          </a:effectRef>
+          <a:fontRef idx="minor">
+            <a:schemeClr val="lt1"/>
+          </a:fontRef>
+        </p:style>
+        <p:txBody>
+          <a:bodyPr rtlCol="0" anchor="ctr" wrap="square" lIns="274320" tIns="164592"/>
+          <a:lstStyle/>
+          <a:p>
+            <a:pPr algn="ctr">
+              <a:defRPr sz="1500">
+                <a:solidFill>
+                  <a:srgbClr val="1E293B"/>
                 </a:solidFill>
                 <a:latin typeface="Arial"/>
               </a:defRPr>
             </a:pPr>
             <a:r>
-              <a:t>•  The system reads live temperature and humidity, shows them on a small screen, and sends the data to a website so anyone can view it anytime.</a:t>
+              <a:t>•   The system reads live temperature and humidity, shows them on a small screen, and sends the data to a website so anyone can view it anytime.</a:t>
             </a:r>
           </a:p>
         </p:txBody>
@@ -3745,14 +4545,57 @@
       <p:grpSpPr/>
       <p:sp>
         <p:nvSpPr>
-          <p:cNvPr id="2" name="TextBox 1"/>
+          <p:cNvPr id="2" name="Rectangle 1"/>
+          <p:cNvSpPr/>
+          <p:nvPr/>
+        </p:nvSpPr>
+        <p:spPr>
+          <a:xfrm>
+            <a:off x="0" y="0"/>
+            <a:ext cx="12191695" cy="73152"/>
+          </a:xfrm>
+          <a:prstGeom prst="rect">
+            <a:avLst/>
+          </a:prstGeom>
+          <a:solidFill>
+            <a:srgbClr val="1A365D"/>
+          </a:solidFill>
+          <a:ln>
+            <a:noFill/>
+          </a:ln>
+        </p:spPr>
+        <p:style>
+          <a:lnRef idx="1">
+            <a:schemeClr val="accent1"/>
+          </a:lnRef>
+          <a:fillRef idx="3">
+            <a:schemeClr val="accent1"/>
+          </a:fillRef>
+          <a:effectRef idx="2">
+            <a:schemeClr val="accent1"/>
+          </a:effectRef>
+          <a:fontRef idx="minor">
+            <a:schemeClr val="lt1"/>
+          </a:fontRef>
+        </p:style>
+        <p:txBody>
+          <a:bodyPr rtlCol="0" anchor="ctr"/>
+          <a:lstStyle/>
+          <a:p>
+            <a:pPr algn="ctr"/>
+          </a:p>
+        </p:txBody>
+      </p:sp>
+      <p:sp>
+        <p:nvSpPr>
+          <p:cNvPr id="3" name="TextBox 2"/>
           <p:cNvSpPr txBox="1"/>
           <p:nvPr/>
         </p:nvSpPr>
         <p:spPr>
           <a:xfrm>
-            <a:off x="914400" y="548640"/>
-            <a:ext cx="10362895" cy="914400"/>
+            <a:off x="914400" y="502920"/>
+            <a:ext cx="10362895" cy="777240"/>
           </a:xfrm>
           <a:prstGeom prst="rect">
             <a:avLst/>
@@ -3768,7 +4611,7 @@
             <a:pPr algn="ctr">
               <a:defRPr sz="2800" b="1">
                 <a:solidFill>
-                  <a:srgbClr val="000000"/>
+                  <a:srgbClr val="1A365D"/>
                 </a:solidFill>
                 <a:latin typeface="Arial"/>
               </a:defRPr>
@@ -3781,87 +4624,295 @@
       </p:sp>
       <p:sp>
         <p:nvSpPr>
-          <p:cNvPr id="3" name="TextBox 2"/>
-          <p:cNvSpPr txBox="1"/>
+          <p:cNvPr id="4" name="Rectangle 3"/>
+          <p:cNvSpPr/>
           <p:nvPr/>
         </p:nvSpPr>
         <p:spPr>
           <a:xfrm>
-            <a:off x="1097280" y="1645920"/>
-            <a:ext cx="10058400" cy="4754880"/>
+            <a:off x="5180990" y="1325880"/>
+            <a:ext cx="1828800" cy="36576"/>
           </a:xfrm>
           <a:prstGeom prst="rect">
             <a:avLst/>
           </a:prstGeom>
-          <a:noFill/>
-        </p:spPr>
-        <p:txBody>
-          <a:bodyPr wrap="square">
-            <a:spAutoFit/>
-          </a:bodyPr>
-          <a:lstStyle/>
-          <a:p>
-            <a:pPr>
-              <a:spcBef>
-                <a:spcPts val="2200"/>
-              </a:spcBef>
-              <a:defRPr sz="1700">
-                <a:solidFill>
-                  <a:srgbClr val="000000"/>
-                </a:solidFill>
-                <a:latin typeface="Arial"/>
-              </a:defRPr>
-            </a:pPr>
-            <a:r>
-              <a:t>•  Need for local weather data: City weather reports are taken far away (like airports) and do not show the exact weather in our room, office, or farm.</a:t>
-            </a:r>
-          </a:p>
-          <a:p>
-            <a:pPr>
-              <a:spcBef>
-                <a:spcPts val="2200"/>
-              </a:spcBef>
-              <a:defRPr sz="1700">
-                <a:solidFill>
-                  <a:srgbClr val="000000"/>
-                </a:solidFill>
-                <a:latin typeface="Arial"/>
-              </a:defRPr>
-            </a:pPr>
-            <a:r>
-              <a:t>•  Low cost: Commercial weather devices cost a lot of money, but this project can be made at a very low cost using simple parts.</a:t>
-            </a:r>
-          </a:p>
-          <a:p>
-            <a:pPr>
-              <a:spcBef>
-                <a:spcPts val="2200"/>
-              </a:spcBef>
-              <a:defRPr sz="1700">
-                <a:solidFill>
-                  <a:srgbClr val="000000"/>
-                </a:solidFill>
-                <a:latin typeface="Arial"/>
-              </a:defRPr>
-            </a:pPr>
-            <a:r>
-              <a:t>•  Real-time monitoring: Instead of writing down values by hand, the system updates automatically every few seconds.</a:t>
-            </a:r>
-          </a:p>
-          <a:p>
-            <a:pPr>
-              <a:spcBef>
-                <a:spcPts val="2200"/>
-              </a:spcBef>
-              <a:defRPr sz="1700">
-                <a:solidFill>
-                  <a:srgbClr val="000000"/>
-                </a:solidFill>
-                <a:latin typeface="Arial"/>
-              </a:defRPr>
-            </a:pPr>
-            <a:r>
-              <a:t>•  Access from anywhere: Anyone with a phone or computer can open our website and check the live weather and past 24-hour charts.</a:t>
+          <a:solidFill>
+            <a:srgbClr val="0D9488"/>
+          </a:solidFill>
+          <a:ln>
+            <a:noFill/>
+          </a:ln>
+        </p:spPr>
+        <p:style>
+          <a:lnRef idx="1">
+            <a:schemeClr val="accent1"/>
+          </a:lnRef>
+          <a:fillRef idx="3">
+            <a:schemeClr val="accent1"/>
+          </a:fillRef>
+          <a:effectRef idx="2">
+            <a:schemeClr val="accent1"/>
+          </a:effectRef>
+          <a:fontRef idx="minor">
+            <a:schemeClr val="lt1"/>
+          </a:fontRef>
+        </p:style>
+        <p:txBody>
+          <a:bodyPr rtlCol="0" anchor="ctr"/>
+          <a:lstStyle/>
+          <a:p>
+            <a:pPr algn="ctr"/>
+          </a:p>
+        </p:txBody>
+      </p:sp>
+      <p:sp>
+        <p:nvSpPr>
+          <p:cNvPr id="5" name="Rounded Rectangle 4"/>
+          <p:cNvSpPr/>
+          <p:nvPr/>
+        </p:nvSpPr>
+        <p:spPr>
+          <a:xfrm>
+            <a:off x="1097280" y="1737360"/>
+            <a:ext cx="9997135" cy="1005840"/>
+          </a:xfrm>
+          <a:prstGeom prst="roundRect">
+            <a:avLst/>
+          </a:prstGeom>
+          <a:solidFill>
+            <a:srgbClr val="F8FAFC"/>
+          </a:solidFill>
+          <a:ln w="12700">
+            <a:solidFill>
+              <a:srgbClr val="E2E8F0"/>
+            </a:solidFill>
+          </a:ln>
+        </p:spPr>
+        <p:style>
+          <a:lnRef idx="1">
+            <a:schemeClr val="accent1"/>
+          </a:lnRef>
+          <a:fillRef idx="3">
+            <a:schemeClr val="accent1"/>
+          </a:fillRef>
+          <a:effectRef idx="2">
+            <a:schemeClr val="accent1"/>
+          </a:effectRef>
+          <a:fontRef idx="minor">
+            <a:schemeClr val="lt1"/>
+          </a:fontRef>
+        </p:style>
+        <p:txBody>
+          <a:bodyPr rtlCol="0" anchor="ctr" wrap="square" lIns="274320" tIns="182880"/>
+          <a:lstStyle/>
+          <a:p>
+            <a:pPr algn="ctr"/>
+            <a:r>
+              <a:rPr b="1" sz="1600">
+                <a:solidFill>
+                  <a:srgbClr val="1A365D"/>
+                </a:solidFill>
+                <a:latin typeface="Arial"/>
+              </a:rPr>
+              <a:t>•   Need for local weather data:</a:t>
+            </a:r>
+            <a:r>
+              <a:rPr b="0" sz="1500">
+                <a:solidFill>
+                  <a:srgbClr val="1E293B"/>
+                </a:solidFill>
+                <a:latin typeface="Arial"/>
+              </a:rPr>
+              <a:t> City weather reports are taken far away (like airports) and do not show the exact weather in our room, office, or farm.</a:t>
+            </a:r>
+          </a:p>
+        </p:txBody>
+      </p:sp>
+      <p:sp>
+        <p:nvSpPr>
+          <p:cNvPr id="6" name="Rounded Rectangle 5"/>
+          <p:cNvSpPr/>
+          <p:nvPr/>
+        </p:nvSpPr>
+        <p:spPr>
+          <a:xfrm>
+            <a:off x="1097280" y="2880360"/>
+            <a:ext cx="9997135" cy="1005840"/>
+          </a:xfrm>
+          <a:prstGeom prst="roundRect">
+            <a:avLst/>
+          </a:prstGeom>
+          <a:solidFill>
+            <a:srgbClr val="F8FAFC"/>
+          </a:solidFill>
+          <a:ln w="12700">
+            <a:solidFill>
+              <a:srgbClr val="E2E8F0"/>
+            </a:solidFill>
+          </a:ln>
+        </p:spPr>
+        <p:style>
+          <a:lnRef idx="1">
+            <a:schemeClr val="accent1"/>
+          </a:lnRef>
+          <a:fillRef idx="3">
+            <a:schemeClr val="accent1"/>
+          </a:fillRef>
+          <a:effectRef idx="2">
+            <a:schemeClr val="accent1"/>
+          </a:effectRef>
+          <a:fontRef idx="minor">
+            <a:schemeClr val="lt1"/>
+          </a:fontRef>
+        </p:style>
+        <p:txBody>
+          <a:bodyPr rtlCol="0" anchor="ctr" wrap="square" lIns="274320" tIns="182880"/>
+          <a:lstStyle/>
+          <a:p>
+            <a:pPr algn="ctr"/>
+            <a:r>
+              <a:rPr b="1" sz="1600">
+                <a:solidFill>
+                  <a:srgbClr val="1A365D"/>
+                </a:solidFill>
+                <a:latin typeface="Arial"/>
+              </a:rPr>
+              <a:t>•   Low cost:</a:t>
+            </a:r>
+            <a:r>
+              <a:rPr b="0" sz="1500">
+                <a:solidFill>
+                  <a:srgbClr val="1E293B"/>
+                </a:solidFill>
+                <a:latin typeface="Arial"/>
+              </a:rPr>
+              <a:t> Commercial weather devices cost a lot of money, but this project can be made at a very low cost using simple parts.</a:t>
+            </a:r>
+          </a:p>
+        </p:txBody>
+      </p:sp>
+      <p:sp>
+        <p:nvSpPr>
+          <p:cNvPr id="7" name="Rounded Rectangle 6"/>
+          <p:cNvSpPr/>
+          <p:nvPr/>
+        </p:nvSpPr>
+        <p:spPr>
+          <a:xfrm>
+            <a:off x="1097280" y="4023360"/>
+            <a:ext cx="9997135" cy="1005840"/>
+          </a:xfrm>
+          <a:prstGeom prst="roundRect">
+            <a:avLst/>
+          </a:prstGeom>
+          <a:solidFill>
+            <a:srgbClr val="F8FAFC"/>
+          </a:solidFill>
+          <a:ln w="12700">
+            <a:solidFill>
+              <a:srgbClr val="E2E8F0"/>
+            </a:solidFill>
+          </a:ln>
+        </p:spPr>
+        <p:style>
+          <a:lnRef idx="1">
+            <a:schemeClr val="accent1"/>
+          </a:lnRef>
+          <a:fillRef idx="3">
+            <a:schemeClr val="accent1"/>
+          </a:fillRef>
+          <a:effectRef idx="2">
+            <a:schemeClr val="accent1"/>
+          </a:effectRef>
+          <a:fontRef idx="minor">
+            <a:schemeClr val="lt1"/>
+          </a:fontRef>
+        </p:style>
+        <p:txBody>
+          <a:bodyPr rtlCol="0" anchor="ctr" wrap="square" lIns="274320" tIns="182880"/>
+          <a:lstStyle/>
+          <a:p>
+            <a:pPr algn="ctr"/>
+            <a:r>
+              <a:rPr b="1" sz="1600">
+                <a:solidFill>
+                  <a:srgbClr val="1A365D"/>
+                </a:solidFill>
+                <a:latin typeface="Arial"/>
+              </a:rPr>
+              <a:t>•   Real-time monitoring:</a:t>
+            </a:r>
+            <a:r>
+              <a:rPr b="0" sz="1500">
+                <a:solidFill>
+                  <a:srgbClr val="1E293B"/>
+                </a:solidFill>
+                <a:latin typeface="Arial"/>
+              </a:rPr>
+              <a:t> Instead of writing down values by hand, the system updates automatically every few seconds.</a:t>
+            </a:r>
+          </a:p>
+        </p:txBody>
+      </p:sp>
+      <p:sp>
+        <p:nvSpPr>
+          <p:cNvPr id="8" name="Rounded Rectangle 7"/>
+          <p:cNvSpPr/>
+          <p:nvPr/>
+        </p:nvSpPr>
+        <p:spPr>
+          <a:xfrm>
+            <a:off x="1097280" y="5166360"/>
+            <a:ext cx="9997135" cy="1005840"/>
+          </a:xfrm>
+          <a:prstGeom prst="roundRect">
+            <a:avLst/>
+          </a:prstGeom>
+          <a:solidFill>
+            <a:srgbClr val="F8FAFC"/>
+          </a:solidFill>
+          <a:ln w="12700">
+            <a:solidFill>
+              <a:srgbClr val="E2E8F0"/>
+            </a:solidFill>
+          </a:ln>
+        </p:spPr>
+        <p:style>
+          <a:lnRef idx="1">
+            <a:schemeClr val="accent1"/>
+          </a:lnRef>
+          <a:fillRef idx="3">
+            <a:schemeClr val="accent1"/>
+          </a:fillRef>
+          <a:effectRef idx="2">
+            <a:schemeClr val="accent1"/>
+          </a:effectRef>
+          <a:fontRef idx="minor">
+            <a:schemeClr val="lt1"/>
+          </a:fontRef>
+        </p:style>
+        <p:txBody>
+          <a:bodyPr rtlCol="0" anchor="ctr" wrap="square" lIns="274320" tIns="182880"/>
+          <a:lstStyle/>
+          <a:p>
+            <a:pPr algn="ctr"/>
+            <a:r>
+              <a:rPr b="1" sz="1600">
+                <a:solidFill>
+                  <a:srgbClr val="1A365D"/>
+                </a:solidFill>
+                <a:latin typeface="Arial"/>
+              </a:rPr>
+              <a:t>•   Access from anywhere:</a:t>
+            </a:r>
+            <a:r>
+              <a:rPr b="0" sz="1500">
+                <a:solidFill>
+                  <a:srgbClr val="1E293B"/>
+                </a:solidFill>
+                <a:latin typeface="Arial"/>
+              </a:rPr>
+              <a:t> Anyone with a phone or computer can open our website and check the live weather and past 24-hour charts.</a:t>
             </a:r>
           </a:p>
         </p:txBody>
@@ -3886,14 +4937,57 @@
       <p:grpSpPr/>
       <p:sp>
         <p:nvSpPr>
-          <p:cNvPr id="2" name="TextBox 1"/>
+          <p:cNvPr id="2" name="Rectangle 1"/>
+          <p:cNvSpPr/>
+          <p:nvPr/>
+        </p:nvSpPr>
+        <p:spPr>
+          <a:xfrm>
+            <a:off x="0" y="0"/>
+            <a:ext cx="12191695" cy="73152"/>
+          </a:xfrm>
+          <a:prstGeom prst="rect">
+            <a:avLst/>
+          </a:prstGeom>
+          <a:solidFill>
+            <a:srgbClr val="1A365D"/>
+          </a:solidFill>
+          <a:ln>
+            <a:noFill/>
+          </a:ln>
+        </p:spPr>
+        <p:style>
+          <a:lnRef idx="1">
+            <a:schemeClr val="accent1"/>
+          </a:lnRef>
+          <a:fillRef idx="3">
+            <a:schemeClr val="accent1"/>
+          </a:fillRef>
+          <a:effectRef idx="2">
+            <a:schemeClr val="accent1"/>
+          </a:effectRef>
+          <a:fontRef idx="minor">
+            <a:schemeClr val="lt1"/>
+          </a:fontRef>
+        </p:style>
+        <p:txBody>
+          <a:bodyPr rtlCol="0" anchor="ctr"/>
+          <a:lstStyle/>
+          <a:p>
+            <a:pPr algn="ctr"/>
+          </a:p>
+        </p:txBody>
+      </p:sp>
+      <p:sp>
+        <p:nvSpPr>
+          <p:cNvPr id="3" name="TextBox 2"/>
           <p:cNvSpPr txBox="1"/>
           <p:nvPr/>
         </p:nvSpPr>
         <p:spPr>
           <a:xfrm>
-            <a:off x="914400" y="548640"/>
-            <a:ext cx="10362895" cy="914400"/>
+            <a:off x="914400" y="502920"/>
+            <a:ext cx="10362895" cy="777240"/>
           </a:xfrm>
           <a:prstGeom prst="rect">
             <a:avLst/>
@@ -3909,7 +5003,7 @@
             <a:pPr algn="ctr">
               <a:defRPr sz="2800" b="1">
                 <a:solidFill>
-                  <a:srgbClr val="000000"/>
+                  <a:srgbClr val="1A365D"/>
                 </a:solidFill>
                 <a:latin typeface="Arial"/>
               </a:defRPr>
@@ -3922,119 +5016,373 @@
       </p:sp>
       <p:sp>
         <p:nvSpPr>
-          <p:cNvPr id="3" name="TextBox 2"/>
-          <p:cNvSpPr txBox="1"/>
+          <p:cNvPr id="4" name="Rectangle 3"/>
+          <p:cNvSpPr/>
           <p:nvPr/>
         </p:nvSpPr>
         <p:spPr>
           <a:xfrm>
-            <a:off x="1097280" y="1645920"/>
-            <a:ext cx="10058400" cy="4754880"/>
+            <a:off x="5180990" y="1325880"/>
+            <a:ext cx="1828800" cy="36576"/>
           </a:xfrm>
           <a:prstGeom prst="rect">
             <a:avLst/>
           </a:prstGeom>
-          <a:noFill/>
-        </p:spPr>
-        <p:txBody>
-          <a:bodyPr wrap="square">
-            <a:spAutoFit/>
-          </a:bodyPr>
-          <a:lstStyle/>
-          <a:p>
-            <a:pPr>
-              <a:spcBef>
-                <a:spcPts val="1800"/>
-              </a:spcBef>
-              <a:defRPr sz="1700">
-                <a:solidFill>
-                  <a:srgbClr val="000000"/>
+          <a:solidFill>
+            <a:srgbClr val="0D9488"/>
+          </a:solidFill>
+          <a:ln>
+            <a:noFill/>
+          </a:ln>
+        </p:spPr>
+        <p:style>
+          <a:lnRef idx="1">
+            <a:schemeClr val="accent1"/>
+          </a:lnRef>
+          <a:fillRef idx="3">
+            <a:schemeClr val="accent1"/>
+          </a:fillRef>
+          <a:effectRef idx="2">
+            <a:schemeClr val="accent1"/>
+          </a:effectRef>
+          <a:fontRef idx="minor">
+            <a:schemeClr val="lt1"/>
+          </a:fontRef>
+        </p:style>
+        <p:txBody>
+          <a:bodyPr rtlCol="0" anchor="ctr"/>
+          <a:lstStyle/>
+          <a:p>
+            <a:pPr algn="ctr"/>
+          </a:p>
+        </p:txBody>
+      </p:sp>
+      <p:sp>
+        <p:nvSpPr>
+          <p:cNvPr id="5" name="Rounded Rectangle 4"/>
+          <p:cNvSpPr/>
+          <p:nvPr/>
+        </p:nvSpPr>
+        <p:spPr>
+          <a:xfrm>
+            <a:off x="1097280" y="1645920"/>
+            <a:ext cx="9997135" cy="676656"/>
+          </a:xfrm>
+          <a:prstGeom prst="roundRect">
+            <a:avLst/>
+          </a:prstGeom>
+          <a:solidFill>
+            <a:srgbClr val="F8FAFC"/>
+          </a:solidFill>
+          <a:ln w="12700">
+            <a:solidFill>
+              <a:srgbClr val="E2E8F0"/>
+            </a:solidFill>
+          </a:ln>
+        </p:spPr>
+        <p:style>
+          <a:lnRef idx="1">
+            <a:schemeClr val="accent1"/>
+          </a:lnRef>
+          <a:fillRef idx="3">
+            <a:schemeClr val="accent1"/>
+          </a:fillRef>
+          <a:effectRef idx="2">
+            <a:schemeClr val="accent1"/>
+          </a:effectRef>
+          <a:fontRef idx="minor">
+            <a:schemeClr val="lt1"/>
+          </a:fontRef>
+        </p:style>
+        <p:txBody>
+          <a:bodyPr rtlCol="0" anchor="ctr" wrap="square" lIns="274320" tIns="128016"/>
+          <a:lstStyle/>
+          <a:p>
+            <a:pPr algn="ctr">
+              <a:defRPr sz="1500">
+                <a:solidFill>
+                  <a:srgbClr val="1E293B"/>
                 </a:solidFill>
                 <a:latin typeface="Arial"/>
               </a:defRPr>
             </a:pPr>
             <a:r>
-              <a:t>•  To build a simple and working smart weather station using ESP32 microcontroller.</a:t>
-            </a:r>
-          </a:p>
-          <a:p>
-            <a:pPr>
-              <a:spcBef>
-                <a:spcPts val="1800"/>
-              </a:spcBef>
-              <a:defRPr sz="1700">
-                <a:solidFill>
-                  <a:srgbClr val="000000"/>
+              <a:t>✔   To build a simple and working smart weather station using ESP32 microcontroller.</a:t>
+            </a:r>
+          </a:p>
+        </p:txBody>
+      </p:sp>
+      <p:sp>
+        <p:nvSpPr>
+          <p:cNvPr id="6" name="Rounded Rectangle 5"/>
+          <p:cNvSpPr/>
+          <p:nvPr/>
+        </p:nvSpPr>
+        <p:spPr>
+          <a:xfrm>
+            <a:off x="1097280" y="2432304"/>
+            <a:ext cx="9997135" cy="676656"/>
+          </a:xfrm>
+          <a:prstGeom prst="roundRect">
+            <a:avLst/>
+          </a:prstGeom>
+          <a:solidFill>
+            <a:srgbClr val="F8FAFC"/>
+          </a:solidFill>
+          <a:ln w="12700">
+            <a:solidFill>
+              <a:srgbClr val="E2E8F0"/>
+            </a:solidFill>
+          </a:ln>
+        </p:spPr>
+        <p:style>
+          <a:lnRef idx="1">
+            <a:schemeClr val="accent1"/>
+          </a:lnRef>
+          <a:fillRef idx="3">
+            <a:schemeClr val="accent1"/>
+          </a:fillRef>
+          <a:effectRef idx="2">
+            <a:schemeClr val="accent1"/>
+          </a:effectRef>
+          <a:fontRef idx="minor">
+            <a:schemeClr val="lt1"/>
+          </a:fontRef>
+        </p:style>
+        <p:txBody>
+          <a:bodyPr rtlCol="0" anchor="ctr" wrap="square" lIns="274320" tIns="128016"/>
+          <a:lstStyle/>
+          <a:p>
+            <a:pPr algn="ctr">
+              <a:defRPr sz="1500">
+                <a:solidFill>
+                  <a:srgbClr val="1E293B"/>
                 </a:solidFill>
                 <a:latin typeface="Arial"/>
               </a:defRPr>
             </a:pPr>
             <a:r>
-              <a:t>•  To accurately measure room temperature and humidity using the DHT22 sensor.</a:t>
-            </a:r>
-          </a:p>
-          <a:p>
-            <a:pPr>
-              <a:spcBef>
-                <a:spcPts val="1800"/>
-              </a:spcBef>
-              <a:defRPr sz="1700">
-                <a:solidFill>
-                  <a:srgbClr val="000000"/>
+              <a:t>✔   To accurately measure room temperature and humidity using the DHT22 sensor.</a:t>
+            </a:r>
+          </a:p>
+        </p:txBody>
+      </p:sp>
+      <p:sp>
+        <p:nvSpPr>
+          <p:cNvPr id="7" name="Rounded Rectangle 6"/>
+          <p:cNvSpPr/>
+          <p:nvPr/>
+        </p:nvSpPr>
+        <p:spPr>
+          <a:xfrm>
+            <a:off x="1097280" y="3218688"/>
+            <a:ext cx="9997135" cy="676656"/>
+          </a:xfrm>
+          <a:prstGeom prst="roundRect">
+            <a:avLst/>
+          </a:prstGeom>
+          <a:solidFill>
+            <a:srgbClr val="F8FAFC"/>
+          </a:solidFill>
+          <a:ln w="12700">
+            <a:solidFill>
+              <a:srgbClr val="E2E8F0"/>
+            </a:solidFill>
+          </a:ln>
+        </p:spPr>
+        <p:style>
+          <a:lnRef idx="1">
+            <a:schemeClr val="accent1"/>
+          </a:lnRef>
+          <a:fillRef idx="3">
+            <a:schemeClr val="accent1"/>
+          </a:fillRef>
+          <a:effectRef idx="2">
+            <a:schemeClr val="accent1"/>
+          </a:effectRef>
+          <a:fontRef idx="minor">
+            <a:schemeClr val="lt1"/>
+          </a:fontRef>
+        </p:style>
+        <p:txBody>
+          <a:bodyPr rtlCol="0" anchor="ctr" wrap="square" lIns="274320" tIns="128016"/>
+          <a:lstStyle/>
+          <a:p>
+            <a:pPr algn="ctr">
+              <a:defRPr sz="1500">
+                <a:solidFill>
+                  <a:srgbClr val="1E293B"/>
                 </a:solidFill>
                 <a:latin typeface="Arial"/>
               </a:defRPr>
             </a:pPr>
             <a:r>
-              <a:t>•  To display the current readings on a small OLED screen placed directly on the board.</a:t>
-            </a:r>
-          </a:p>
-          <a:p>
-            <a:pPr>
-              <a:spcBef>
-                <a:spcPts val="1800"/>
-              </a:spcBef>
-              <a:defRPr sz="1700">
-                <a:solidFill>
-                  <a:srgbClr val="000000"/>
+              <a:t>✔   To display the current readings on a small OLED screen placed directly on the board.</a:t>
+            </a:r>
+          </a:p>
+        </p:txBody>
+      </p:sp>
+      <p:sp>
+        <p:nvSpPr>
+          <p:cNvPr id="8" name="Rounded Rectangle 7"/>
+          <p:cNvSpPr/>
+          <p:nvPr/>
+        </p:nvSpPr>
+        <p:spPr>
+          <a:xfrm>
+            <a:off x="1097280" y="4005072"/>
+            <a:ext cx="9997135" cy="676656"/>
+          </a:xfrm>
+          <a:prstGeom prst="roundRect">
+            <a:avLst/>
+          </a:prstGeom>
+          <a:solidFill>
+            <a:srgbClr val="F8FAFC"/>
+          </a:solidFill>
+          <a:ln w="12700">
+            <a:solidFill>
+              <a:srgbClr val="E2E8F0"/>
+            </a:solidFill>
+          </a:ln>
+        </p:spPr>
+        <p:style>
+          <a:lnRef idx="1">
+            <a:schemeClr val="accent1"/>
+          </a:lnRef>
+          <a:fillRef idx="3">
+            <a:schemeClr val="accent1"/>
+          </a:fillRef>
+          <a:effectRef idx="2">
+            <a:schemeClr val="accent1"/>
+          </a:effectRef>
+          <a:fontRef idx="minor">
+            <a:schemeClr val="lt1"/>
+          </a:fontRef>
+        </p:style>
+        <p:txBody>
+          <a:bodyPr rtlCol="0" anchor="ctr" wrap="square" lIns="274320" tIns="128016"/>
+          <a:lstStyle/>
+          <a:p>
+            <a:pPr algn="ctr">
+              <a:defRPr sz="1500">
+                <a:solidFill>
+                  <a:srgbClr val="1E293B"/>
                 </a:solidFill>
                 <a:latin typeface="Arial"/>
               </a:defRPr>
             </a:pPr>
             <a:r>
-              <a:t>•  To calculate Heat Index (how hot it feels) and Dew Point to check human comfort.</a:t>
-            </a:r>
-          </a:p>
-          <a:p>
-            <a:pPr>
-              <a:spcBef>
-                <a:spcPts val="1800"/>
-              </a:spcBef>
-              <a:defRPr sz="1700">
-                <a:solidFill>
-                  <a:srgbClr val="000000"/>
+              <a:t>✔   To calculate Heat Index (how hot it feels) and Dew Point to check human comfort.</a:t>
+            </a:r>
+          </a:p>
+        </p:txBody>
+      </p:sp>
+      <p:sp>
+        <p:nvSpPr>
+          <p:cNvPr id="9" name="Rounded Rectangle 8"/>
+          <p:cNvSpPr/>
+          <p:nvPr/>
+        </p:nvSpPr>
+        <p:spPr>
+          <a:xfrm>
+            <a:off x="1097280" y="4791456"/>
+            <a:ext cx="9997135" cy="676656"/>
+          </a:xfrm>
+          <a:prstGeom prst="roundRect">
+            <a:avLst/>
+          </a:prstGeom>
+          <a:solidFill>
+            <a:srgbClr val="F8FAFC"/>
+          </a:solidFill>
+          <a:ln w="12700">
+            <a:solidFill>
+              <a:srgbClr val="E2E8F0"/>
+            </a:solidFill>
+          </a:ln>
+        </p:spPr>
+        <p:style>
+          <a:lnRef idx="1">
+            <a:schemeClr val="accent1"/>
+          </a:lnRef>
+          <a:fillRef idx="3">
+            <a:schemeClr val="accent1"/>
+          </a:fillRef>
+          <a:effectRef idx="2">
+            <a:schemeClr val="accent1"/>
+          </a:effectRef>
+          <a:fontRef idx="minor">
+            <a:schemeClr val="lt1"/>
+          </a:fontRef>
+        </p:style>
+        <p:txBody>
+          <a:bodyPr rtlCol="0" anchor="ctr" wrap="square" lIns="274320" tIns="128016"/>
+          <a:lstStyle/>
+          <a:p>
+            <a:pPr algn="ctr">
+              <a:defRPr sz="1500">
+                <a:solidFill>
+                  <a:srgbClr val="1E293B"/>
                 </a:solidFill>
                 <a:latin typeface="Arial"/>
               </a:defRPr>
             </a:pPr>
             <a:r>
-              <a:t>•  To send all sensor data to the ThingSpeak cloud platform over Wi-Fi every 20 seconds.</a:t>
-            </a:r>
-          </a:p>
-          <a:p>
-            <a:pPr>
-              <a:spcBef>
-                <a:spcPts val="1800"/>
-              </a:spcBef>
-              <a:defRPr sz="1700">
-                <a:solidFill>
-                  <a:srgbClr val="000000"/>
+              <a:t>✔   To send all sensor data to the ThingSpeak cloud platform over Wi-Fi every 20 seconds.</a:t>
+            </a:r>
+          </a:p>
+        </p:txBody>
+      </p:sp>
+      <p:sp>
+        <p:nvSpPr>
+          <p:cNvPr id="10" name="Rounded Rectangle 9"/>
+          <p:cNvSpPr/>
+          <p:nvPr/>
+        </p:nvSpPr>
+        <p:spPr>
+          <a:xfrm>
+            <a:off x="1097280" y="5577840"/>
+            <a:ext cx="9997135" cy="676656"/>
+          </a:xfrm>
+          <a:prstGeom prst="roundRect">
+            <a:avLst/>
+          </a:prstGeom>
+          <a:solidFill>
+            <a:srgbClr val="F8FAFC"/>
+          </a:solidFill>
+          <a:ln w="12700">
+            <a:solidFill>
+              <a:srgbClr val="E2E8F0"/>
+            </a:solidFill>
+          </a:ln>
+        </p:spPr>
+        <p:style>
+          <a:lnRef idx="1">
+            <a:schemeClr val="accent1"/>
+          </a:lnRef>
+          <a:fillRef idx="3">
+            <a:schemeClr val="accent1"/>
+          </a:fillRef>
+          <a:effectRef idx="2">
+            <a:schemeClr val="accent1"/>
+          </a:effectRef>
+          <a:fontRef idx="minor">
+            <a:schemeClr val="lt1"/>
+          </a:fontRef>
+        </p:style>
+        <p:txBody>
+          <a:bodyPr rtlCol="0" anchor="ctr" wrap="square" lIns="274320" tIns="128016"/>
+          <a:lstStyle/>
+          <a:p>
+            <a:pPr algn="ctr">
+              <a:defRPr sz="1500">
+                <a:solidFill>
+                  <a:srgbClr val="1E293B"/>
                 </a:solidFill>
                 <a:latin typeface="Arial"/>
               </a:defRPr>
             </a:pPr>
             <a:r>
-              <a:t>•  To show live readings and a 24-hour history graph on an online website hosted on Vercel.</a:t>
+              <a:t>✔   To show live readings and a 24-hour history graph on an online website hosted on Vercel.</a:t>
             </a:r>
           </a:p>
         </p:txBody>
@@ -4059,14 +5407,57 @@
       <p:grpSpPr/>
       <p:sp>
         <p:nvSpPr>
-          <p:cNvPr id="2" name="TextBox 1"/>
+          <p:cNvPr id="2" name="Rectangle 1"/>
+          <p:cNvSpPr/>
+          <p:nvPr/>
+        </p:nvSpPr>
+        <p:spPr>
+          <a:xfrm>
+            <a:off x="0" y="0"/>
+            <a:ext cx="12191695" cy="73152"/>
+          </a:xfrm>
+          <a:prstGeom prst="rect">
+            <a:avLst/>
+          </a:prstGeom>
+          <a:solidFill>
+            <a:srgbClr val="1A365D"/>
+          </a:solidFill>
+          <a:ln>
+            <a:noFill/>
+          </a:ln>
+        </p:spPr>
+        <p:style>
+          <a:lnRef idx="1">
+            <a:schemeClr val="accent1"/>
+          </a:lnRef>
+          <a:fillRef idx="3">
+            <a:schemeClr val="accent1"/>
+          </a:fillRef>
+          <a:effectRef idx="2">
+            <a:schemeClr val="accent1"/>
+          </a:effectRef>
+          <a:fontRef idx="minor">
+            <a:schemeClr val="lt1"/>
+          </a:fontRef>
+        </p:style>
+        <p:txBody>
+          <a:bodyPr rtlCol="0" anchor="ctr"/>
+          <a:lstStyle/>
+          <a:p>
+            <a:pPr algn="ctr"/>
+          </a:p>
+        </p:txBody>
+      </p:sp>
+      <p:sp>
+        <p:nvSpPr>
+          <p:cNvPr id="3" name="TextBox 2"/>
           <p:cNvSpPr txBox="1"/>
           <p:nvPr/>
         </p:nvSpPr>
         <p:spPr>
           <a:xfrm>
-            <a:off x="914400" y="548640"/>
-            <a:ext cx="10362895" cy="914400"/>
+            <a:off x="914400" y="502920"/>
+            <a:ext cx="10362895" cy="777240"/>
           </a:xfrm>
           <a:prstGeom prst="rect">
             <a:avLst/>
@@ -4082,7 +5473,7 @@
             <a:pPr algn="ctr">
               <a:defRPr sz="2800" b="1">
                 <a:solidFill>
-                  <a:srgbClr val="000000"/>
+                  <a:srgbClr val="1A365D"/>
                 </a:solidFill>
                 <a:latin typeface="Arial"/>
               </a:defRPr>
@@ -4095,39 +5486,311 @@
       </p:sp>
       <p:sp>
         <p:nvSpPr>
-          <p:cNvPr id="3" name="TextBox 2"/>
-          <p:cNvSpPr txBox="1"/>
+          <p:cNvPr id="4" name="Rectangle 3"/>
+          <p:cNvSpPr/>
           <p:nvPr/>
         </p:nvSpPr>
         <p:spPr>
           <a:xfrm>
-            <a:off x="1097280" y="1645920"/>
-            <a:ext cx="10058400" cy="4754880"/>
+            <a:off x="5180990" y="1325880"/>
+            <a:ext cx="1828800" cy="36576"/>
           </a:xfrm>
           <a:prstGeom prst="rect">
             <a:avLst/>
           </a:prstGeom>
-          <a:noFill/>
-        </p:spPr>
-        <p:txBody>
-          <a:bodyPr wrap="square">
-            <a:spAutoFit/>
-          </a:bodyPr>
-          <a:lstStyle/>
+          <a:solidFill>
+            <a:srgbClr val="0D9488"/>
+          </a:solidFill>
+          <a:ln>
+            <a:noFill/>
+          </a:ln>
+        </p:spPr>
+        <p:style>
+          <a:lnRef idx="1">
+            <a:schemeClr val="accent1"/>
+          </a:lnRef>
+          <a:fillRef idx="3">
+            <a:schemeClr val="accent1"/>
+          </a:fillRef>
+          <a:effectRef idx="2">
+            <a:schemeClr val="accent1"/>
+          </a:effectRef>
+          <a:fontRef idx="minor">
+            <a:schemeClr val="lt1"/>
+          </a:fontRef>
+        </p:style>
+        <p:txBody>
+          <a:bodyPr rtlCol="0" anchor="ctr"/>
+          <a:lstStyle/>
+          <a:p>
+            <a:pPr algn="ctr"/>
+          </a:p>
+        </p:txBody>
+      </p:sp>
+      <p:sp>
+        <p:nvSpPr>
+          <p:cNvPr id="5" name="Rounded Rectangle 4"/>
+          <p:cNvSpPr/>
+          <p:nvPr/>
+        </p:nvSpPr>
+        <p:spPr>
+          <a:xfrm>
+            <a:off x="1097280" y="1645920"/>
+            <a:ext cx="3154680" cy="2011680"/>
+          </a:xfrm>
+          <a:prstGeom prst="roundRect">
+            <a:avLst/>
+          </a:prstGeom>
+          <a:solidFill>
+            <a:srgbClr val="F8FAFC"/>
+          </a:solidFill>
+          <a:ln w="12700">
+            <a:solidFill>
+              <a:srgbClr val="E2E8F0"/>
+            </a:solidFill>
+          </a:ln>
+        </p:spPr>
+        <p:style>
+          <a:lnRef idx="1">
+            <a:schemeClr val="accent1"/>
+          </a:lnRef>
+          <a:fillRef idx="3">
+            <a:schemeClr val="accent1"/>
+          </a:fillRef>
+          <a:effectRef idx="2">
+            <a:schemeClr val="accent1"/>
+          </a:effectRef>
+          <a:fontRef idx="minor">
+            <a:schemeClr val="lt1"/>
+          </a:fontRef>
+        </p:style>
+        <p:txBody>
+          <a:bodyPr rtlCol="0" anchor="ctr" wrap="square" lIns="228600" tIns="182880"/>
+          <a:lstStyle/>
+          <a:p>
+            <a:pPr algn="ctr">
+              <a:defRPr sz="1500" b="1">
+                <a:solidFill>
+                  <a:srgbClr val="1A365D"/>
+                </a:solidFill>
+                <a:latin typeface="Arial"/>
+              </a:defRPr>
+            </a:pPr>
+            <a:r>
+              <a:t>1. ESP32 Microcontroller</a:t>
+            </a:r>
+          </a:p>
           <a:p>
             <a:pPr>
               <a:spcBef>
-                <a:spcPts val="1200"/>
+                <a:spcPts val="800"/>
               </a:spcBef>
+              <a:defRPr sz="1300">
+                <a:solidFill>
+                  <a:srgbClr val="1E293B"/>
+                </a:solidFill>
+                <a:latin typeface="Arial"/>
+              </a:defRPr>
+            </a:pPr>
+            <a:r>
+              <a:t>The main brain with built-in Wi-Fi to collect sensor data and send it to the cloud.</a:t>
+            </a:r>
+          </a:p>
+        </p:txBody>
+      </p:sp>
+      <p:sp>
+        <p:nvSpPr>
+          <p:cNvPr id="6" name="Rounded Rectangle 5"/>
+          <p:cNvSpPr/>
+          <p:nvPr/>
+        </p:nvSpPr>
+        <p:spPr>
+          <a:xfrm>
+            <a:off x="4526280" y="1645920"/>
+            <a:ext cx="3154680" cy="2011680"/>
+          </a:xfrm>
+          <a:prstGeom prst="roundRect">
+            <a:avLst/>
+          </a:prstGeom>
+          <a:solidFill>
+            <a:srgbClr val="F8FAFC"/>
+          </a:solidFill>
+          <a:ln w="12700">
+            <a:solidFill>
+              <a:srgbClr val="E2E8F0"/>
+            </a:solidFill>
+          </a:ln>
+        </p:spPr>
+        <p:style>
+          <a:lnRef idx="1">
+            <a:schemeClr val="accent1"/>
+          </a:lnRef>
+          <a:fillRef idx="3">
+            <a:schemeClr val="accent1"/>
+          </a:fillRef>
+          <a:effectRef idx="2">
+            <a:schemeClr val="accent1"/>
+          </a:effectRef>
+          <a:fontRef idx="minor">
+            <a:schemeClr val="lt1"/>
+          </a:fontRef>
+        </p:style>
+        <p:txBody>
+          <a:bodyPr rtlCol="0" anchor="ctr" wrap="square" lIns="228600" tIns="182880"/>
+          <a:lstStyle/>
+          <a:p>
+            <a:pPr algn="ctr">
+              <a:defRPr sz="1500" b="1">
+                <a:solidFill>
+                  <a:srgbClr val="1A365D"/>
+                </a:solidFill>
+                <a:latin typeface="Arial"/>
+              </a:defRPr>
+            </a:pPr>
+            <a:r>
+              <a:t>2. DHT22 Sensor</a:t>
+            </a:r>
+          </a:p>
+          <a:p>
+            <a:pPr>
+              <a:spcBef>
+                <a:spcPts val="800"/>
+              </a:spcBef>
+              <a:defRPr sz="1300">
+                <a:solidFill>
+                  <a:srgbClr val="1E293B"/>
+                </a:solidFill>
+                <a:latin typeface="Arial"/>
+              </a:defRPr>
+            </a:pPr>
+            <a:r>
+              <a:t>Measures temperature (-40°C to 80°C) and humidity (0 to 100%) with high accuracy.</a:t>
+            </a:r>
+          </a:p>
+        </p:txBody>
+      </p:sp>
+      <p:sp>
+        <p:nvSpPr>
+          <p:cNvPr id="7" name="Rounded Rectangle 6"/>
+          <p:cNvSpPr/>
+          <p:nvPr/>
+        </p:nvSpPr>
+        <p:spPr>
+          <a:xfrm>
+            <a:off x="7955279" y="1645920"/>
+            <a:ext cx="3154680" cy="2011680"/>
+          </a:xfrm>
+          <a:prstGeom prst="roundRect">
+            <a:avLst/>
+          </a:prstGeom>
+          <a:solidFill>
+            <a:srgbClr val="F8FAFC"/>
+          </a:solidFill>
+          <a:ln w="12700">
+            <a:solidFill>
+              <a:srgbClr val="E2E8F0"/>
+            </a:solidFill>
+          </a:ln>
+        </p:spPr>
+        <p:style>
+          <a:lnRef idx="1">
+            <a:schemeClr val="accent1"/>
+          </a:lnRef>
+          <a:fillRef idx="3">
+            <a:schemeClr val="accent1"/>
+          </a:fillRef>
+          <a:effectRef idx="2">
+            <a:schemeClr val="accent1"/>
+          </a:effectRef>
+          <a:fontRef idx="minor">
+            <a:schemeClr val="lt1"/>
+          </a:fontRef>
+        </p:style>
+        <p:txBody>
+          <a:bodyPr rtlCol="0" anchor="ctr" wrap="square" lIns="228600" tIns="182880"/>
+          <a:lstStyle/>
+          <a:p>
+            <a:pPr algn="ctr">
+              <a:defRPr sz="1500" b="1">
+                <a:solidFill>
+                  <a:srgbClr val="1A365D"/>
+                </a:solidFill>
+                <a:latin typeface="Arial"/>
+              </a:defRPr>
+            </a:pPr>
+            <a:r>
+              <a:t>3. SSD1306 OLED Display</a:t>
+            </a:r>
+          </a:p>
+          <a:p>
+            <a:pPr>
+              <a:spcBef>
+                <a:spcPts val="800"/>
+              </a:spcBef>
+              <a:defRPr sz="1300">
+                <a:solidFill>
+                  <a:srgbClr val="1E293B"/>
+                </a:solidFill>
+                <a:latin typeface="Arial"/>
+              </a:defRPr>
+            </a:pPr>
+            <a:r>
+              <a:t>Small 0.96-inch screen that shows live values directly on the device.</a:t>
+            </a:r>
+          </a:p>
+        </p:txBody>
+      </p:sp>
+      <p:sp>
+        <p:nvSpPr>
+          <p:cNvPr id="8" name="Rounded Rectangle 7"/>
+          <p:cNvSpPr/>
+          <p:nvPr/>
+        </p:nvSpPr>
+        <p:spPr>
+          <a:xfrm>
+            <a:off x="1097280" y="3931920"/>
+            <a:ext cx="9997135" cy="2377440"/>
+          </a:xfrm>
+          <a:prstGeom prst="roundRect">
+            <a:avLst/>
+          </a:prstGeom>
+          <a:solidFill>
+            <a:srgbClr val="F8FAFC"/>
+          </a:solidFill>
+          <a:ln w="19050">
+            <a:solidFill>
+              <a:srgbClr val="0D9488"/>
+            </a:solidFill>
+          </a:ln>
+        </p:spPr>
+        <p:style>
+          <a:lnRef idx="1">
+            <a:schemeClr val="accent1"/>
+          </a:lnRef>
+          <a:fillRef idx="3">
+            <a:schemeClr val="accent1"/>
+          </a:fillRef>
+          <a:effectRef idx="2">
+            <a:schemeClr val="accent1"/>
+          </a:effectRef>
+          <a:fontRef idx="minor">
+            <a:schemeClr val="lt1"/>
+          </a:fontRef>
+        </p:style>
+        <p:txBody>
+          <a:bodyPr rtlCol="0" anchor="ctr" wrap="square" lIns="274320" tIns="182880"/>
+          <a:lstStyle/>
+          <a:p>
+            <a:pPr algn="ctr">
               <a:defRPr sz="1600" b="1">
                 <a:solidFill>
-                  <a:srgbClr val="000000"/>
+                  <a:srgbClr val="1A365D"/>
                 </a:solidFill>
                 <a:latin typeface="Arial"/>
               </a:defRPr>
             </a:pPr>
             <a:r>
-              <a:t>Hardware components used:</a:t>
+              <a:t>Wiring and Connections:</a:t>
             </a:r>
           </a:p>
           <a:p>
@@ -4135,15 +5798,15 @@
               <a:spcBef>
                 <a:spcPts val="400"/>
               </a:spcBef>
-              <a:defRPr sz="1500" b="0">
-                <a:solidFill>
-                  <a:srgbClr val="000000"/>
+              <a:defRPr sz="1400">
+                <a:solidFill>
+                  <a:srgbClr val="1E293B"/>
                 </a:solidFill>
                 <a:latin typeface="Arial"/>
               </a:defRPr>
             </a:pPr>
             <a:r>
-              <a:t>    1. ESP32 Microcontroller: The main brain with built-in Wi-Fi to collect and send data.</a:t>
+              <a:t>• DHT22 data pin is connected to ESP32 Pin GPIO 4.</a:t>
             </a:r>
           </a:p>
           <a:p>
@@ -4151,15 +5814,15 @@
               <a:spcBef>
                 <a:spcPts val="400"/>
               </a:spcBef>
-              <a:defRPr sz="1500" b="0">
-                <a:solidFill>
-                  <a:srgbClr val="000000"/>
+              <a:defRPr sz="1400">
+                <a:solidFill>
+                  <a:srgbClr val="1E293B"/>
                 </a:solidFill>
                 <a:latin typeface="Arial"/>
               </a:defRPr>
             </a:pPr>
             <a:r>
-              <a:t>    2. DHT22 Sensor: Measures temperature (from -40°C to 80°C) and humidity (0 to 100%).</a:t>
+              <a:t>• OLED display is connected using I2C wires (SDA to GPIO 21, SCL to GPIO 22).</a:t>
             </a:r>
           </a:p>
           <a:p>
@@ -4167,15 +5830,15 @@
               <a:spcBef>
                 <a:spcPts val="400"/>
               </a:spcBef>
-              <a:defRPr sz="1500" b="0">
-                <a:solidFill>
-                  <a:srgbClr val="000000"/>
+              <a:defRPr sz="1400">
+                <a:solidFill>
+                  <a:srgbClr val="1E293B"/>
                 </a:solidFill>
                 <a:latin typeface="Arial"/>
               </a:defRPr>
             </a:pPr>
             <a:r>
-              <a:t>    3. SSD1306 OLED Display: Small 0.96-inch screen to see the values on the device.</a:t>
+              <a:t>• 3.3V and GND power pins are shared between the sensor and screen.</a:t>
             </a:r>
           </a:p>
           <a:p>
@@ -4183,28 +5846,15 @@
               <a:spcBef>
                 <a:spcPts val="400"/>
               </a:spcBef>
-              <a:defRPr sz="1500" b="0">
-                <a:solidFill>
-                  <a:srgbClr val="000000"/>
+              <a:defRPr sz="1400" b="1">
+                <a:solidFill>
+                  <a:srgbClr val="1A365D"/>
                 </a:solidFill>
                 <a:latin typeface="Arial"/>
               </a:defRPr>
             </a:pPr>
-          </a:p>
-          <a:p>
-            <a:pPr>
-              <a:spcBef>
-                <a:spcPts val="1200"/>
-              </a:spcBef>
-              <a:defRPr sz="1600" b="1">
-                <a:solidFill>
-                  <a:srgbClr val="000000"/>
-                </a:solidFill>
-                <a:latin typeface="Arial"/>
-              </a:defRPr>
-            </a:pPr>
-            <a:r>
-              <a:t>Wiring and Connections:</a:t>
+            <a:r>
+              <a:t>Working Flow:</a:t>
             </a:r>
           </a:p>
           <a:p>
@@ -4212,92 +5862,15 @@
               <a:spcBef>
                 <a:spcPts val="400"/>
               </a:spcBef>
-              <a:defRPr sz="1500" b="0">
-                <a:solidFill>
-                  <a:srgbClr val="000000"/>
+              <a:defRPr sz="1400" b="1">
+                <a:solidFill>
+                  <a:srgbClr val="0D9488"/>
                 </a:solidFill>
                 <a:latin typeface="Arial"/>
               </a:defRPr>
             </a:pPr>
             <a:r>
-              <a:t>    • DHT22 data pin is connected to ESP32 Pin GPIO 4.</a:t>
-            </a:r>
-          </a:p>
-          <a:p>
-            <a:pPr>
-              <a:spcBef>
-                <a:spcPts val="400"/>
-              </a:spcBef>
-              <a:defRPr sz="1500" b="0">
-                <a:solidFill>
-                  <a:srgbClr val="000000"/>
-                </a:solidFill>
-                <a:latin typeface="Arial"/>
-              </a:defRPr>
-            </a:pPr>
-            <a:r>
-              <a:t>    • OLED display is connected using I2C wires (SDA to GPIO 21, SCL to GPIO 22).</a:t>
-            </a:r>
-          </a:p>
-          <a:p>
-            <a:pPr>
-              <a:spcBef>
-                <a:spcPts val="400"/>
-              </a:spcBef>
-              <a:defRPr sz="1500" b="0">
-                <a:solidFill>
-                  <a:srgbClr val="000000"/>
-                </a:solidFill>
-                <a:latin typeface="Arial"/>
-              </a:defRPr>
-            </a:pPr>
-            <a:r>
-              <a:t>    • 3.3V and GND power pins are shared between the sensor and screen.</a:t>
-            </a:r>
-          </a:p>
-          <a:p>
-            <a:pPr>
-              <a:spcBef>
-                <a:spcPts val="400"/>
-              </a:spcBef>
-              <a:defRPr sz="1500" b="0">
-                <a:solidFill>
-                  <a:srgbClr val="000000"/>
-                </a:solidFill>
-                <a:latin typeface="Arial"/>
-              </a:defRPr>
-            </a:pPr>
-          </a:p>
-          <a:p>
-            <a:pPr>
-              <a:spcBef>
-                <a:spcPts val="1200"/>
-              </a:spcBef>
-              <a:defRPr sz="1600" b="1">
-                <a:solidFill>
-                  <a:srgbClr val="000000"/>
-                </a:solidFill>
-                <a:latin typeface="Arial"/>
-              </a:defRPr>
-            </a:pPr>
-            <a:r>
-              <a:t>Working Steps:</a:t>
-            </a:r>
-          </a:p>
-          <a:p>
-            <a:pPr>
-              <a:spcBef>
-                <a:spcPts val="400"/>
-              </a:spcBef>
-              <a:defRPr sz="1500" b="0">
-                <a:solidFill>
-                  <a:srgbClr val="000000"/>
-                </a:solidFill>
-                <a:latin typeface="Arial"/>
-              </a:defRPr>
-            </a:pPr>
-            <a:r>
-              <a:t>    Sensor reads data  ➔  ESP32 calculates comfort values  ➔  Shows on OLED  ➔  Sends to ThingSpeak cloud via Wi-Fi.</a:t>
+              <a:t>    DHT22 reads data  ➔  ESP32 calculates values  ➔  Shows on OLED  ➔  Sends to ThingSpeak Cloud  ➔  Vercel Website</a:t>
             </a:r>
           </a:p>
         </p:txBody>
@@ -4322,14 +5895,57 @@
       <p:grpSpPr/>
       <p:sp>
         <p:nvSpPr>
-          <p:cNvPr id="2" name="TextBox 1"/>
+          <p:cNvPr id="2" name="Rectangle 1"/>
+          <p:cNvSpPr/>
+          <p:nvPr/>
+        </p:nvSpPr>
+        <p:spPr>
+          <a:xfrm>
+            <a:off x="0" y="0"/>
+            <a:ext cx="12191695" cy="73152"/>
+          </a:xfrm>
+          <a:prstGeom prst="rect">
+            <a:avLst/>
+          </a:prstGeom>
+          <a:solidFill>
+            <a:srgbClr val="1A365D"/>
+          </a:solidFill>
+          <a:ln>
+            <a:noFill/>
+          </a:ln>
+        </p:spPr>
+        <p:style>
+          <a:lnRef idx="1">
+            <a:schemeClr val="accent1"/>
+          </a:lnRef>
+          <a:fillRef idx="3">
+            <a:schemeClr val="accent1"/>
+          </a:fillRef>
+          <a:effectRef idx="2">
+            <a:schemeClr val="accent1"/>
+          </a:effectRef>
+          <a:fontRef idx="minor">
+            <a:schemeClr val="lt1"/>
+          </a:fontRef>
+        </p:style>
+        <p:txBody>
+          <a:bodyPr rtlCol="0" anchor="ctr"/>
+          <a:lstStyle/>
+          <a:p>
+            <a:pPr algn="ctr"/>
+          </a:p>
+        </p:txBody>
+      </p:sp>
+      <p:sp>
+        <p:nvSpPr>
+          <p:cNvPr id="3" name="TextBox 2"/>
           <p:cNvSpPr txBox="1"/>
           <p:nvPr/>
         </p:nvSpPr>
         <p:spPr>
           <a:xfrm>
-            <a:off x="914400" y="548640"/>
-            <a:ext cx="10362895" cy="914400"/>
+            <a:off x="914400" y="502920"/>
+            <a:ext cx="10362895" cy="777240"/>
           </a:xfrm>
           <a:prstGeom prst="rect">
             <a:avLst/>
@@ -4345,7 +5961,7 @@
             <a:pPr algn="ctr">
               <a:defRPr sz="2800" b="1">
                 <a:solidFill>
-                  <a:srgbClr val="000000"/>
+                  <a:srgbClr val="1A365D"/>
                 </a:solidFill>
                 <a:latin typeface="Arial"/>
               </a:defRPr>
@@ -4358,51 +5974,58 @@
       </p:sp>
       <p:sp>
         <p:nvSpPr>
-          <p:cNvPr id="3" name="TextBox 2"/>
-          <p:cNvSpPr txBox="1"/>
+          <p:cNvPr id="4" name="Rectangle 3"/>
+          <p:cNvSpPr/>
           <p:nvPr/>
         </p:nvSpPr>
         <p:spPr>
           <a:xfrm>
-            <a:off x="1097280" y="1371600"/>
-            <a:ext cx="10058400" cy="548640"/>
+            <a:off x="5180990" y="1325880"/>
+            <a:ext cx="1828800" cy="36576"/>
           </a:xfrm>
           <a:prstGeom prst="rect">
             <a:avLst/>
           </a:prstGeom>
-          <a:noFill/>
-        </p:spPr>
-        <p:txBody>
-          <a:bodyPr wrap="none">
-            <a:spAutoFit/>
-          </a:bodyPr>
-          <a:lstStyle/>
-          <a:p>
-            <a:pPr>
-              <a:defRPr sz="1800" b="1">
-                <a:solidFill>
-                  <a:srgbClr val="000000"/>
-                </a:solidFill>
-                <a:latin typeface="Arial"/>
-              </a:defRPr>
-            </a:pPr>
-            <a:r>
-              <a:t>Results and Live Cloud Data:</a:t>
-            </a:r>
+          <a:solidFill>
+            <a:srgbClr val="0D9488"/>
+          </a:solidFill>
+          <a:ln>
+            <a:noFill/>
+          </a:ln>
+        </p:spPr>
+        <p:style>
+          <a:lnRef idx="1">
+            <a:schemeClr val="accent1"/>
+          </a:lnRef>
+          <a:fillRef idx="3">
+            <a:schemeClr val="accent1"/>
+          </a:fillRef>
+          <a:effectRef idx="2">
+            <a:schemeClr val="accent1"/>
+          </a:effectRef>
+          <a:fontRef idx="minor">
+            <a:schemeClr val="lt1"/>
+          </a:fontRef>
+        </p:style>
+        <p:txBody>
+          <a:bodyPr rtlCol="0" anchor="ctr"/>
+          <a:lstStyle/>
+          <a:p>
+            <a:pPr algn="ctr"/>
           </a:p>
         </p:txBody>
       </p:sp>
       <p:graphicFrame>
         <p:nvGraphicFramePr>
-          <p:cNvPr id="4" name="Table 3"/>
+          <p:cNvPr id="5" name="Table 4"/>
           <p:cNvGraphicFramePr>
             <a:graphicFrameLocks noGrp="1"/>
           </p:cNvGraphicFramePr>
           <p:nvPr/>
         </p:nvGraphicFramePr>
         <p:xfrm>
-          <a:off x="1097280" y="2011680"/>
-          <a:ext cx="10058400" cy="2011680"/>
+          <a:off x="1097280" y="1691640"/>
+          <a:ext cx="5303520" cy="2377440"/>
         </p:xfrm>
         <a:graphic>
           <a:graphicData uri="http://schemas.openxmlformats.org/drawingml/2006/table">
@@ -4411,18 +6034,18 @@
                 <a:tableStyleId>{5C22544A-7EE6-4342-B048-85BDC9FD1C3A}</a:tableStyleId>
               </a:tblPr>
               <a:tblGrid>
-                <a:gridCol w="3200400"/>
-                <a:gridCol w="3200400"/>
-                <a:gridCol w="3657600"/>
+                <a:gridCol w="1828800"/>
+                <a:gridCol w="1645920"/>
+                <a:gridCol w="1828800"/>
               </a:tblGrid>
-              <a:tr h="402336">
+              <a:tr h="475488">
                 <a:tc>
                   <a:txBody>
                     <a:bodyPr/>
                     <a:lstStyle/>
                     <a:p>
                       <a:pPr>
-                        <a:defRPr sz="1400" b="1">
+                        <a:defRPr sz="1300" b="1">
                           <a:solidFill>
                             <a:srgbClr val="FFFFFF"/>
                           </a:solidFill>
@@ -4436,7 +6059,7 @@
                   </a:txBody>
                   <a:tcPr>
                     <a:solidFill>
-                      <a:srgbClr val="4682B4"/>
+                      <a:srgbClr val="1A365D"/>
                     </a:solidFill>
                   </a:tcPr>
                 </a:tc>
@@ -4446,7 +6069,7 @@
                     <a:lstStyle/>
                     <a:p>
                       <a:pPr>
-                        <a:defRPr sz="1400" b="1">
+                        <a:defRPr sz="1300" b="1">
                           <a:solidFill>
                             <a:srgbClr val="FFFFFF"/>
                           </a:solidFill>
@@ -4454,13 +6077,13 @@
                         </a:defRPr>
                       </a:pPr>
                       <a:r>
-                        <a:t>Live Measured Value</a:t>
+                        <a:t>Live Value</a:t>
                       </a:r>
                     </a:p>
                   </a:txBody>
                   <a:tcPr>
                     <a:solidFill>
-                      <a:srgbClr val="4682B4"/>
+                      <a:srgbClr val="1A365D"/>
                     </a:solidFill>
                   </a:tcPr>
                 </a:tc>
@@ -4470,7 +6093,7 @@
                     <a:lstStyle/>
                     <a:p>
                       <a:pPr>
-                        <a:defRPr sz="1400" b="1">
+                        <a:defRPr sz="1300" b="1">
                           <a:solidFill>
                             <a:srgbClr val="FFFFFF"/>
                           </a:solidFill>
@@ -4484,12 +6107,12 @@
                   </a:txBody>
                   <a:tcPr>
                     <a:solidFill>
-                      <a:srgbClr val="4682B4"/>
+                      <a:srgbClr val="1A365D"/>
                     </a:solidFill>
                   </a:tcPr>
                 </a:tc>
               </a:tr>
-              <a:tr h="402336">
+              <a:tr h="475488">
                 <a:tc>
                   <a:txBody>
                     <a:bodyPr/>
@@ -4498,7 +6121,7 @@
                       <a:pPr>
                         <a:defRPr sz="1300">
                           <a:solidFill>
-                            <a:srgbClr val="000000"/>
+                            <a:srgbClr val="1E293B"/>
                           </a:solidFill>
                           <a:latin typeface="Arial"/>
                         </a:defRPr>
@@ -4510,7 +6133,7 @@
                   </a:txBody>
                   <a:tcPr>
                     <a:solidFill>
-                      <a:srgbClr val="E6F0FA"/>
+                      <a:srgbClr val="F8FAFC"/>
                     </a:solidFill>
                   </a:tcPr>
                 </a:tc>
@@ -4522,7 +6145,7 @@
                       <a:pPr>
                         <a:defRPr sz="1300">
                           <a:solidFill>
-                            <a:srgbClr val="000000"/>
+                            <a:srgbClr val="1E293B"/>
                           </a:solidFill>
                           <a:latin typeface="Arial"/>
                         </a:defRPr>
@@ -4534,7 +6157,7 @@
                   </a:txBody>
                   <a:tcPr>
                     <a:solidFill>
-                      <a:srgbClr val="E6F0FA"/>
+                      <a:srgbClr val="F8FAFC"/>
                     </a:solidFill>
                   </a:tcPr>
                 </a:tc>
@@ -4546,24 +6169,24 @@
                       <a:pPr>
                         <a:defRPr sz="1300">
                           <a:solidFill>
-                            <a:srgbClr val="000000"/>
+                            <a:srgbClr val="1E293B"/>
                           </a:solidFill>
                           <a:latin typeface="Arial"/>
                         </a:defRPr>
                       </a:pPr>
                       <a:r>
-                        <a:t>Current room temperature</a:t>
+                        <a:t>Room temperature</a:t>
                       </a:r>
                     </a:p>
                   </a:txBody>
                   <a:tcPr>
                     <a:solidFill>
-                      <a:srgbClr val="E6F0FA"/>
+                      <a:srgbClr val="F8FAFC"/>
                     </a:solidFill>
                   </a:tcPr>
                 </a:tc>
               </a:tr>
-              <a:tr h="402336">
+              <a:tr h="475488">
                 <a:tc>
                   <a:txBody>
                     <a:bodyPr/>
@@ -4572,7 +6195,7 @@
                       <a:pPr>
                         <a:defRPr sz="1300">
                           <a:solidFill>
-                            <a:srgbClr val="000000"/>
+                            <a:srgbClr val="1E293B"/>
                           </a:solidFill>
                           <a:latin typeface="Arial"/>
                         </a:defRPr>
@@ -4596,7 +6219,7 @@
                       <a:pPr>
                         <a:defRPr sz="1300">
                           <a:solidFill>
-                            <a:srgbClr val="000000"/>
+                            <a:srgbClr val="1E293B"/>
                           </a:solidFill>
                           <a:latin typeface="Arial"/>
                         </a:defRPr>
@@ -4620,13 +6243,13 @@
                       <a:pPr>
                         <a:defRPr sz="1300">
                           <a:solidFill>
-                            <a:srgbClr val="000000"/>
+                            <a:srgbClr val="1E293B"/>
                           </a:solidFill>
                           <a:latin typeface="Arial"/>
                         </a:defRPr>
                       </a:pPr>
                       <a:r>
-                        <a:t>Current moisture in air</a:t>
+                        <a:t>Moisture in air</a:t>
                       </a:r>
                     </a:p>
                   </a:txBody>
@@ -4637,7 +6260,7 @@
                   </a:tcPr>
                 </a:tc>
               </a:tr>
-              <a:tr h="402336">
+              <a:tr h="475488">
                 <a:tc>
                   <a:txBody>
                     <a:bodyPr/>
@@ -4646,7 +6269,7 @@
                       <a:pPr>
                         <a:defRPr sz="1300">
                           <a:solidFill>
-                            <a:srgbClr val="000000"/>
+                            <a:srgbClr val="1E293B"/>
                           </a:solidFill>
                           <a:latin typeface="Arial"/>
                         </a:defRPr>
@@ -4658,7 +6281,7 @@
                   </a:txBody>
                   <a:tcPr>
                     <a:solidFill>
-                      <a:srgbClr val="E6F0FA"/>
+                      <a:srgbClr val="F8FAFC"/>
                     </a:solidFill>
                   </a:tcPr>
                 </a:tc>
@@ -4670,7 +6293,7 @@
                       <a:pPr>
                         <a:defRPr sz="1300">
                           <a:solidFill>
-                            <a:srgbClr val="000000"/>
+                            <a:srgbClr val="1E293B"/>
                           </a:solidFill>
                           <a:latin typeface="Arial"/>
                         </a:defRPr>
@@ -4682,7 +6305,7 @@
                   </a:txBody>
                   <a:tcPr>
                     <a:solidFill>
-                      <a:srgbClr val="E6F0FA"/>
+                      <a:srgbClr val="F8FAFC"/>
                     </a:solidFill>
                   </a:tcPr>
                 </a:tc>
@@ -4694,7 +6317,7 @@
                       <a:pPr>
                         <a:defRPr sz="1300">
                           <a:solidFill>
-                            <a:srgbClr val="000000"/>
+                            <a:srgbClr val="1E293B"/>
                           </a:solidFill>
                           <a:latin typeface="Arial"/>
                         </a:defRPr>
@@ -4706,12 +6329,12 @@
                   </a:txBody>
                   <a:tcPr>
                     <a:solidFill>
-                      <a:srgbClr val="E6F0FA"/>
+                      <a:srgbClr val="F8FAFC"/>
                     </a:solidFill>
                   </a:tcPr>
                 </a:tc>
               </a:tr>
-              <a:tr h="402336">
+              <a:tr h="475488">
                 <a:tc>
                   <a:txBody>
                     <a:bodyPr/>
@@ -4720,7 +6343,7 @@
                       <a:pPr>
                         <a:defRPr sz="1300">
                           <a:solidFill>
-                            <a:srgbClr val="000000"/>
+                            <a:srgbClr val="1E293B"/>
                           </a:solidFill>
                           <a:latin typeface="Arial"/>
                         </a:defRPr>
@@ -4744,7 +6367,7 @@
                       <a:pPr>
                         <a:defRPr sz="1300">
                           <a:solidFill>
-                            <a:srgbClr val="000000"/>
+                            <a:srgbClr val="1E293B"/>
                           </a:solidFill>
                           <a:latin typeface="Arial"/>
                         </a:defRPr>
@@ -4768,13 +6391,13 @@
                       <a:pPr>
                         <a:defRPr sz="1300">
                           <a:solidFill>
-                            <a:srgbClr val="000000"/>
+                            <a:srgbClr val="1E293B"/>
                           </a:solidFill>
                           <a:latin typeface="Arial"/>
                         </a:defRPr>
                       </a:pPr>
                       <a:r>
-                        <a:t>Comfort and moisture level</a:t>
+                        <a:t>Moisture comfort</a:t>
                       </a:r>
                     </a:p>
                   </a:txBody>
@@ -4791,49 +6414,81 @@
       </p:graphicFrame>
       <p:sp>
         <p:nvSpPr>
-          <p:cNvPr id="5" name="TextBox 4"/>
-          <p:cNvSpPr txBox="1"/>
+          <p:cNvPr id="6" name="Rounded Rectangle 5"/>
+          <p:cNvSpPr/>
           <p:nvPr/>
         </p:nvSpPr>
         <p:spPr>
           <a:xfrm>
-            <a:off x="1097280" y="4297680"/>
-            <a:ext cx="10058400" cy="2011680"/>
-          </a:xfrm>
-          <a:prstGeom prst="rect">
+            <a:off x="6675120" y="1691640"/>
+            <a:ext cx="4419295" cy="4389120"/>
+          </a:xfrm>
+          <a:prstGeom prst="roundRect">
             <a:avLst/>
           </a:prstGeom>
-          <a:noFill/>
-        </p:spPr>
-        <p:txBody>
-          <a:bodyPr wrap="square">
-            <a:spAutoFit/>
-          </a:bodyPr>
-          <a:lstStyle/>
+          <a:solidFill>
+            <a:srgbClr val="F8FAFC"/>
+          </a:solidFill>
+          <a:ln w="19050">
+            <a:solidFill>
+              <a:srgbClr val="0D9488"/>
+            </a:solidFill>
+          </a:ln>
+        </p:spPr>
+        <p:style>
+          <a:lnRef idx="1">
+            <a:schemeClr val="accent1"/>
+          </a:lnRef>
+          <a:fillRef idx="3">
+            <a:schemeClr val="accent1"/>
+          </a:fillRef>
+          <a:effectRef idx="2">
+            <a:schemeClr val="accent1"/>
+          </a:effectRef>
+          <a:fontRef idx="minor">
+            <a:schemeClr val="lt1"/>
+          </a:fontRef>
+        </p:style>
+        <p:txBody>
+          <a:bodyPr rtlCol="0" anchor="ctr" wrap="square" lIns="274320" tIns="228600"/>
+          <a:lstStyle/>
+          <a:p>
+            <a:pPr algn="ctr">
+              <a:defRPr sz="1600" b="1">
+                <a:solidFill>
+                  <a:srgbClr val="1A365D"/>
+                </a:solidFill>
+                <a:latin typeface="Arial"/>
+              </a:defRPr>
+            </a:pPr>
+            <a:r>
+              <a:t>Live Website &amp; Cloud Features:</a:t>
+            </a:r>
+          </a:p>
           <a:p>
             <a:pPr>
               <a:spcBef>
-                <a:spcPts val="800"/>
+                <a:spcPts val="1000"/>
               </a:spcBef>
-              <a:defRPr sz="1400">
-                <a:solidFill>
-                  <a:srgbClr val="000000"/>
+              <a:defRPr sz="1300">
+                <a:solidFill>
+                  <a:srgbClr val="1E293B"/>
                 </a:solidFill>
                 <a:latin typeface="Arial"/>
               </a:defRPr>
             </a:pPr>
             <a:r>
-              <a:t>• The system uploads new data to ThingSpeak every 20 seconds.</a:t>
+              <a:t>• ESP32 sends new data to ThingSpeak every 20 seconds.</a:t>
             </a:r>
           </a:p>
           <a:p>
             <a:pPr>
               <a:spcBef>
-                <a:spcPts val="800"/>
+                <a:spcPts val="1000"/>
               </a:spcBef>
-              <a:defRPr sz="1400">
-                <a:solidFill>
-                  <a:srgbClr val="000000"/>
+              <a:defRPr sz="1300">
+                <a:solidFill>
+                  <a:srgbClr val="1E293B"/>
                 </a:solidFill>
                 <a:latin typeface="Arial"/>
               </a:defRPr>
@@ -4845,49 +6500,128 @@
           <a:p>
             <a:pPr>
               <a:spcBef>
-                <a:spcPts val="800"/>
+                <a:spcPts val="1000"/>
               </a:spcBef>
-              <a:defRPr sz="1400">
-                <a:solidFill>
-                  <a:srgbClr val="000000"/>
+              <a:defRPr sz="1300">
+                <a:solidFill>
+                  <a:srgbClr val="1E293B"/>
                 </a:solidFill>
                 <a:latin typeface="Arial"/>
               </a:defRPr>
             </a:pPr>
             <a:r>
-              <a:t>• A clean 24-hour graph draws temperature and humidity history directly in the browser.</a:t>
+              <a:t>• A clean 24-hour graph draws temperature and humidity history directly in browser.</a:t>
             </a:r>
           </a:p>
           <a:p>
             <a:pPr>
               <a:spcBef>
-                <a:spcPts val="800"/>
+                <a:spcPts val="1000"/>
               </a:spcBef>
-              <a:defRPr sz="1400" b="1">
-                <a:solidFill>
-                  <a:srgbClr val="000000"/>
+              <a:defRPr sz="1300" b="1">
+                <a:solidFill>
+                  <a:srgbClr val="1A365D"/>
                 </a:solidFill>
                 <a:latin typeface="Arial"/>
               </a:defRPr>
             </a:pPr>
             <a:r>
-              <a:t>• Live Website URL: https://smart-weather-station.vercel.app/</a:t>
+              <a:t>• Live Website URL:</a:t>
+            </a:r>
+            <a:br/>
+            <a:r>
+              <a:t>   https://smart-weather-station.vercel.app/</a:t>
             </a:r>
           </a:p>
           <a:p>
             <a:pPr>
               <a:spcBef>
-                <a:spcPts val="800"/>
+                <a:spcPts val="1000"/>
               </a:spcBef>
-              <a:defRPr sz="1400" b="1">
-                <a:solidFill>
-                  <a:srgbClr val="000000"/>
+              <a:defRPr sz="1300" b="1">
+                <a:solidFill>
+                  <a:srgbClr val="1A365D"/>
                 </a:solidFill>
                 <a:latin typeface="Arial"/>
               </a:defRPr>
             </a:pPr>
             <a:r>
-              <a:t>• Project Code on GitHub: https://github.com/prasoon9999/smart-weather-station</a:t>
+              <a:t>• Project Code on GitHub:</a:t>
+            </a:r>
+            <a:br/>
+            <a:r>
+              <a:t>   https://github.com/prasoon9999/smart-weather-station</a:t>
+            </a:r>
+          </a:p>
+        </p:txBody>
+      </p:sp>
+      <p:sp>
+        <p:nvSpPr>
+          <p:cNvPr id="7" name="Rounded Rectangle 6"/>
+          <p:cNvSpPr/>
+          <p:nvPr/>
+        </p:nvSpPr>
+        <p:spPr>
+          <a:xfrm>
+            <a:off x="1097280" y="4297680"/>
+            <a:ext cx="5303520" cy="1783080"/>
+          </a:xfrm>
+          <a:prstGeom prst="roundRect">
+            <a:avLst/>
+          </a:prstGeom>
+          <a:solidFill>
+            <a:srgbClr val="F8FAFC"/>
+          </a:solidFill>
+          <a:ln w="12700">
+            <a:solidFill>
+              <a:srgbClr val="E2E8F0"/>
+            </a:solidFill>
+          </a:ln>
+        </p:spPr>
+        <p:style>
+          <a:lnRef idx="1">
+            <a:schemeClr val="accent1"/>
+          </a:lnRef>
+          <a:fillRef idx="3">
+            <a:schemeClr val="accent1"/>
+          </a:fillRef>
+          <a:effectRef idx="2">
+            <a:schemeClr val="accent1"/>
+          </a:effectRef>
+          <a:fontRef idx="minor">
+            <a:schemeClr val="lt1"/>
+          </a:fontRef>
+        </p:style>
+        <p:txBody>
+          <a:bodyPr rtlCol="0" anchor="ctr" lIns="228600" tIns="182880"/>
+          <a:lstStyle/>
+          <a:p>
+            <a:pPr algn="ctr">
+              <a:defRPr sz="1500" b="1">
+                <a:solidFill>
+                  <a:srgbClr val="1A365D"/>
+                </a:solidFill>
+                <a:latin typeface="Arial"/>
+              </a:defRPr>
+            </a:pPr>
+            <a:r>
+              <a:t>Telemetry Verification:</a:t>
+            </a:r>
+          </a:p>
+          <a:p>
+            <a:pPr>
+              <a:spcBef>
+                <a:spcPts val="600"/>
+              </a:spcBef>
+              <a:defRPr sz="1300">
+                <a:solidFill>
+                  <a:srgbClr val="1E293B"/>
+                </a:solidFill>
+                <a:latin typeface="Arial"/>
+              </a:defRPr>
+            </a:pPr>
+            <a:r>
+              <a:t>All readings have been verified live on MathWorks ThingSpeak Channel 3531601 with over 60 continuous entries received from our hardware prototype.</a:t>
             </a:r>
           </a:p>
         </p:txBody>
@@ -4912,14 +6646,57 @@
       <p:grpSpPr/>
       <p:sp>
         <p:nvSpPr>
-          <p:cNvPr id="2" name="TextBox 1"/>
+          <p:cNvPr id="2" name="Rectangle 1"/>
+          <p:cNvSpPr/>
+          <p:nvPr/>
+        </p:nvSpPr>
+        <p:spPr>
+          <a:xfrm>
+            <a:off x="0" y="0"/>
+            <a:ext cx="12191695" cy="73152"/>
+          </a:xfrm>
+          <a:prstGeom prst="rect">
+            <a:avLst/>
+          </a:prstGeom>
+          <a:solidFill>
+            <a:srgbClr val="1A365D"/>
+          </a:solidFill>
+          <a:ln>
+            <a:noFill/>
+          </a:ln>
+        </p:spPr>
+        <p:style>
+          <a:lnRef idx="1">
+            <a:schemeClr val="accent1"/>
+          </a:lnRef>
+          <a:fillRef idx="3">
+            <a:schemeClr val="accent1"/>
+          </a:fillRef>
+          <a:effectRef idx="2">
+            <a:schemeClr val="accent1"/>
+          </a:effectRef>
+          <a:fontRef idx="minor">
+            <a:schemeClr val="lt1"/>
+          </a:fontRef>
+        </p:style>
+        <p:txBody>
+          <a:bodyPr rtlCol="0" anchor="ctr"/>
+          <a:lstStyle/>
+          <a:p>
+            <a:pPr algn="ctr"/>
+          </a:p>
+        </p:txBody>
+      </p:sp>
+      <p:sp>
+        <p:nvSpPr>
+          <p:cNvPr id="3" name="TextBox 2"/>
           <p:cNvSpPr txBox="1"/>
           <p:nvPr/>
         </p:nvSpPr>
         <p:spPr>
           <a:xfrm>
-            <a:off x="914400" y="548640"/>
-            <a:ext cx="10362895" cy="914400"/>
+            <a:off x="914400" y="502920"/>
+            <a:ext cx="10362895" cy="777240"/>
           </a:xfrm>
           <a:prstGeom prst="rect">
             <a:avLst/>
@@ -4935,7 +6712,7 @@
             <a:pPr algn="ctr">
               <a:defRPr sz="2800" b="1">
                 <a:solidFill>
-                  <a:srgbClr val="000000"/>
+                  <a:srgbClr val="1A365D"/>
                 </a:solidFill>
                 <a:latin typeface="Arial"/>
               </a:defRPr>
@@ -4948,151 +6725,265 @@
       </p:sp>
       <p:sp>
         <p:nvSpPr>
-          <p:cNvPr id="3" name="TextBox 2"/>
-          <p:cNvSpPr txBox="1"/>
+          <p:cNvPr id="4" name="Rectangle 3"/>
+          <p:cNvSpPr/>
           <p:nvPr/>
         </p:nvSpPr>
         <p:spPr>
           <a:xfrm>
-            <a:off x="1097280" y="1645920"/>
-            <a:ext cx="10058400" cy="4754880"/>
+            <a:off x="5180990" y="1325880"/>
+            <a:ext cx="1828800" cy="36576"/>
           </a:xfrm>
           <a:prstGeom prst="rect">
             <a:avLst/>
           </a:prstGeom>
-          <a:noFill/>
-        </p:spPr>
-        <p:txBody>
-          <a:bodyPr wrap="square">
-            <a:spAutoFit/>
-          </a:bodyPr>
-          <a:lstStyle/>
+          <a:solidFill>
+            <a:srgbClr val="0D9488"/>
+          </a:solidFill>
+          <a:ln>
+            <a:noFill/>
+          </a:ln>
+        </p:spPr>
+        <p:style>
+          <a:lnRef idx="1">
+            <a:schemeClr val="accent1"/>
+          </a:lnRef>
+          <a:fillRef idx="3">
+            <a:schemeClr val="accent1"/>
+          </a:fillRef>
+          <a:effectRef idx="2">
+            <a:schemeClr val="accent1"/>
+          </a:effectRef>
+          <a:fontRef idx="minor">
+            <a:schemeClr val="lt1"/>
+          </a:fontRef>
+        </p:style>
+        <p:txBody>
+          <a:bodyPr rtlCol="0" anchor="ctr"/>
+          <a:lstStyle/>
+          <a:p>
+            <a:pPr algn="ctr"/>
+          </a:p>
+        </p:txBody>
+      </p:sp>
+      <p:sp>
+        <p:nvSpPr>
+          <p:cNvPr id="5" name="Rounded Rectangle 4"/>
+          <p:cNvSpPr/>
+          <p:nvPr/>
+        </p:nvSpPr>
+        <p:spPr>
+          <a:xfrm>
+            <a:off x="1097280" y="1645920"/>
+            <a:ext cx="9997135" cy="2194560"/>
+          </a:xfrm>
+          <a:prstGeom prst="roundRect">
+            <a:avLst/>
+          </a:prstGeom>
+          <a:solidFill>
+            <a:srgbClr val="F8FAFC"/>
+          </a:solidFill>
+          <a:ln w="12700">
+            <a:solidFill>
+              <a:srgbClr val="E2E8F0"/>
+            </a:solidFill>
+          </a:ln>
+        </p:spPr>
+        <p:style>
+          <a:lnRef idx="1">
+            <a:schemeClr val="accent1"/>
+          </a:lnRef>
+          <a:fillRef idx="3">
+            <a:schemeClr val="accent1"/>
+          </a:fillRef>
+          <a:effectRef idx="2">
+            <a:schemeClr val="accent1"/>
+          </a:effectRef>
+          <a:fontRef idx="minor">
+            <a:schemeClr val="lt1"/>
+          </a:fontRef>
+        </p:style>
+        <p:txBody>
+          <a:bodyPr rtlCol="0" anchor="ctr" wrap="square" lIns="274320" tIns="182880"/>
+          <a:lstStyle/>
+          <a:p>
+            <a:pPr algn="ctr">
+              <a:defRPr sz="1600" b="1">
+                <a:solidFill>
+                  <a:srgbClr val="1A365D"/>
+                </a:solidFill>
+                <a:latin typeface="Arial"/>
+              </a:defRPr>
+            </a:pPr>
+            <a:r>
+              <a:t>Summary of Work:</a:t>
+            </a:r>
+          </a:p>
           <a:p>
             <a:pPr>
               <a:spcBef>
-                <a:spcPts val="1600"/>
+                <a:spcPts val="400"/>
               </a:spcBef>
-              <a:defRPr sz="1600" b="0">
-                <a:solidFill>
-                  <a:srgbClr val="000000"/>
+              <a:defRPr sz="1400">
+                <a:solidFill>
+                  <a:srgbClr val="1E293B"/>
                 </a:solidFill>
                 <a:latin typeface="Arial"/>
               </a:defRPr>
             </a:pPr>
             <a:r>
-              <a:t>•  A low-cost and working Smart Weather Station was successfully built using ESP32.</a:t>
+              <a:t>• A low-cost and working Smart Weather Station was successfully built using ESP32.</a:t>
             </a:r>
           </a:p>
           <a:p>
             <a:pPr>
               <a:spcBef>
-                <a:spcPts val="1600"/>
+                <a:spcPts val="400"/>
               </a:spcBef>
-              <a:defRPr sz="1600" b="0">
-                <a:solidFill>
-                  <a:srgbClr val="000000"/>
+              <a:defRPr sz="1400">
+                <a:solidFill>
+                  <a:srgbClr val="1E293B"/>
                 </a:solidFill>
                 <a:latin typeface="Arial"/>
               </a:defRPr>
             </a:pPr>
             <a:r>
-              <a:t>•  The DHT22 sensor gives accurate temperature and humidity readings in real time.</a:t>
+              <a:t>• The DHT22 sensor gives accurate temperature and humidity readings in real time.</a:t>
             </a:r>
           </a:p>
           <a:p>
             <a:pPr>
               <a:spcBef>
-                <a:spcPts val="1600"/>
+                <a:spcPts val="400"/>
               </a:spcBef>
-              <a:defRPr sz="1600" b="0">
-                <a:solidFill>
-                  <a:srgbClr val="000000"/>
+              <a:defRPr sz="1400">
+                <a:solidFill>
+                  <a:srgbClr val="1E293B"/>
                 </a:solidFill>
                 <a:latin typeface="Arial"/>
               </a:defRPr>
             </a:pPr>
             <a:r>
-              <a:t>•  The OLED display allows us to easily check values without needing an internet connection.</a:t>
+              <a:t>• The OLED display allows us to easily check values without needing an internet connection.</a:t>
             </a:r>
           </a:p>
           <a:p>
             <a:pPr>
               <a:spcBef>
-                <a:spcPts val="1600"/>
+                <a:spcPts val="400"/>
               </a:spcBef>
-              <a:defRPr sz="1600" b="0">
-                <a:solidFill>
-                  <a:srgbClr val="000000"/>
+              <a:defRPr sz="1400">
+                <a:solidFill>
+                  <a:srgbClr val="1E293B"/>
                 </a:solidFill>
                 <a:latin typeface="Arial"/>
               </a:defRPr>
             </a:pPr>
             <a:r>
-              <a:t>•  The ThingSpeak cloud and Vercel website make it simple for anyone to see weather data from anywhere.</a:t>
+              <a:t>• The ThingSpeak cloud and Vercel website make it simple for anyone to see weather data from anywhere.</a:t>
+            </a:r>
+          </a:p>
+        </p:txBody>
+      </p:sp>
+      <p:sp>
+        <p:nvSpPr>
+          <p:cNvPr id="6" name="Rounded Rectangle 5"/>
+          <p:cNvSpPr/>
+          <p:nvPr/>
+        </p:nvSpPr>
+        <p:spPr>
+          <a:xfrm>
+            <a:off x="1097280" y="4069080"/>
+            <a:ext cx="9997135" cy="2194560"/>
+          </a:xfrm>
+          <a:prstGeom prst="roundRect">
+            <a:avLst/>
+          </a:prstGeom>
+          <a:solidFill>
+            <a:srgbClr val="F8FAFC"/>
+          </a:solidFill>
+          <a:ln w="19050">
+            <a:solidFill>
+              <a:srgbClr val="0D9488"/>
+            </a:solidFill>
+          </a:ln>
+        </p:spPr>
+        <p:style>
+          <a:lnRef idx="1">
+            <a:schemeClr val="accent1"/>
+          </a:lnRef>
+          <a:fillRef idx="3">
+            <a:schemeClr val="accent1"/>
+          </a:fillRef>
+          <a:effectRef idx="2">
+            <a:schemeClr val="accent1"/>
+          </a:effectRef>
+          <a:fontRef idx="minor">
+            <a:schemeClr val="lt1"/>
+          </a:fontRef>
+        </p:style>
+        <p:txBody>
+          <a:bodyPr rtlCol="0" anchor="ctr" wrap="square" lIns="274320" tIns="182880"/>
+          <a:lstStyle/>
+          <a:p>
+            <a:pPr algn="ctr">
+              <a:defRPr sz="1600" b="1">
+                <a:solidFill>
+                  <a:srgbClr val="0D9488"/>
+                </a:solidFill>
+                <a:latin typeface="Arial"/>
+              </a:defRPr>
+            </a:pPr>
+            <a:r>
+              <a:t>Future Scope:</a:t>
             </a:r>
           </a:p>
           <a:p>
             <a:pPr>
               <a:spcBef>
-                <a:spcPts val="1600"/>
+                <a:spcPts val="600"/>
               </a:spcBef>
-              <a:defRPr sz="1700" b="1">
-                <a:solidFill>
-                  <a:srgbClr val="000000"/>
+              <a:defRPr sz="1400">
+                <a:solidFill>
+                  <a:srgbClr val="1E293B"/>
                 </a:solidFill>
                 <a:latin typeface="Arial"/>
               </a:defRPr>
             </a:pPr>
             <a:r>
-              <a:t>Future Scope:</a:t>
+              <a:t>• Add a pressure sensor (BMP280) to measure atmospheric pressure and altitude.</a:t>
             </a:r>
           </a:p>
           <a:p>
             <a:pPr>
               <a:spcBef>
-                <a:spcPts val="800"/>
+                <a:spcPts val="600"/>
               </a:spcBef>
-              <a:defRPr sz="1600" b="0">
-                <a:solidFill>
-                  <a:srgbClr val="000000"/>
+              <a:defRPr sz="1400">
+                <a:solidFill>
+                  <a:srgbClr val="1E293B"/>
                 </a:solidFill>
                 <a:latin typeface="Arial"/>
               </a:defRPr>
             </a:pPr>
             <a:r>
-              <a:t>    • Add a pressure sensor (BMP280) to measure atmospheric pressure and altitude.</a:t>
+              <a:t>• Add a small solar panel and battery so it can run outdoors without a power plug.</a:t>
             </a:r>
           </a:p>
           <a:p>
             <a:pPr>
               <a:spcBef>
-                <a:spcPts val="800"/>
+                <a:spcPts val="600"/>
               </a:spcBef>
-              <a:defRPr sz="1600" b="0">
-                <a:solidFill>
-                  <a:srgbClr val="000000"/>
+              <a:defRPr sz="1400">
+                <a:solidFill>
+                  <a:srgbClr val="1E293B"/>
                 </a:solidFill>
                 <a:latin typeface="Arial"/>
               </a:defRPr>
             </a:pPr>
             <a:r>
-              <a:t>    • Add a small solar panel and battery so it can run outdoors without a power plug.</a:t>
-            </a:r>
-          </a:p>
-          <a:p>
-            <a:pPr>
-              <a:spcBef>
-                <a:spcPts val="800"/>
-              </a:spcBef>
-              <a:defRPr sz="1600" b="0">
-                <a:solidFill>
-                  <a:srgbClr val="000000"/>
-                </a:solidFill>
-                <a:latin typeface="Arial"/>
-              </a:defRPr>
-            </a:pPr>
-            <a:r>
-              <a:t>    • Send SMS or mobile alerts if the temperature gets too high.</a:t>
+              <a:t>• Send SMS or mobile alerts if the temperature gets too high.</a:t>
             </a:r>
           </a:p>
         </p:txBody>
@@ -5117,14 +7008,57 @@
       <p:grpSpPr/>
       <p:sp>
         <p:nvSpPr>
-          <p:cNvPr id="2" name="TextBox 1"/>
+          <p:cNvPr id="2" name="Rectangle 1"/>
+          <p:cNvSpPr/>
+          <p:nvPr/>
+        </p:nvSpPr>
+        <p:spPr>
+          <a:xfrm>
+            <a:off x="0" y="0"/>
+            <a:ext cx="12191695" cy="73152"/>
+          </a:xfrm>
+          <a:prstGeom prst="rect">
+            <a:avLst/>
+          </a:prstGeom>
+          <a:solidFill>
+            <a:srgbClr val="1A365D"/>
+          </a:solidFill>
+          <a:ln>
+            <a:noFill/>
+          </a:ln>
+        </p:spPr>
+        <p:style>
+          <a:lnRef idx="1">
+            <a:schemeClr val="accent1"/>
+          </a:lnRef>
+          <a:fillRef idx="3">
+            <a:schemeClr val="accent1"/>
+          </a:fillRef>
+          <a:effectRef idx="2">
+            <a:schemeClr val="accent1"/>
+          </a:effectRef>
+          <a:fontRef idx="minor">
+            <a:schemeClr val="lt1"/>
+          </a:fontRef>
+        </p:style>
+        <p:txBody>
+          <a:bodyPr rtlCol="0" anchor="ctr"/>
+          <a:lstStyle/>
+          <a:p>
+            <a:pPr algn="ctr"/>
+          </a:p>
+        </p:txBody>
+      </p:sp>
+      <p:sp>
+        <p:nvSpPr>
+          <p:cNvPr id="3" name="TextBox 2"/>
           <p:cNvSpPr txBox="1"/>
           <p:nvPr/>
         </p:nvSpPr>
         <p:spPr>
           <a:xfrm>
-            <a:off x="914400" y="548640"/>
-            <a:ext cx="10362895" cy="914400"/>
+            <a:off x="914400" y="502920"/>
+            <a:ext cx="10362895" cy="777240"/>
           </a:xfrm>
           <a:prstGeom prst="rect">
             <a:avLst/>
@@ -5140,7 +7074,7 @@
             <a:pPr algn="ctr">
               <a:defRPr sz="2800" b="1">
                 <a:solidFill>
-                  <a:srgbClr val="000000"/>
+                  <a:srgbClr val="1A365D"/>
                 </a:solidFill>
                 <a:latin typeface="Arial"/>
               </a:defRPr>
@@ -5148,20 +7082,63 @@
             <a:r>
               <a:t>REFERENCES:-</a:t>
             </a:r>
+          </a:p>
+        </p:txBody>
+      </p:sp>
+      <p:sp>
+        <p:nvSpPr>
+          <p:cNvPr id="4" name="Rectangle 3"/>
+          <p:cNvSpPr/>
+          <p:nvPr/>
+        </p:nvSpPr>
+        <p:spPr>
+          <a:xfrm>
+            <a:off x="5180990" y="1325880"/>
+            <a:ext cx="1828800" cy="36576"/>
+          </a:xfrm>
+          <a:prstGeom prst="rect">
+            <a:avLst/>
+          </a:prstGeom>
+          <a:solidFill>
+            <a:srgbClr val="0D9488"/>
+          </a:solidFill>
+          <a:ln>
+            <a:noFill/>
+          </a:ln>
+        </p:spPr>
+        <p:style>
+          <a:lnRef idx="1">
+            <a:schemeClr val="accent1"/>
+          </a:lnRef>
+          <a:fillRef idx="3">
+            <a:schemeClr val="accent1"/>
+          </a:fillRef>
+          <a:effectRef idx="2">
+            <a:schemeClr val="accent1"/>
+          </a:effectRef>
+          <a:fontRef idx="minor">
+            <a:schemeClr val="lt1"/>
+          </a:fontRef>
+        </p:style>
+        <p:txBody>
+          <a:bodyPr rtlCol="0" anchor="ctr"/>
+          <a:lstStyle/>
+          <a:p>
+            <a:pPr algn="ctr"/>
           </a:p>
         </p:txBody>
       </p:sp>
       <p:graphicFrame>
         <p:nvGraphicFramePr>
-          <p:cNvPr id="3" name="Table 2"/>
+          <p:cNvPr id="5" name="Table 4"/>
           <p:cNvGraphicFramePr>
             <a:graphicFrameLocks noGrp="1"/>
           </p:cNvGraphicFramePr>
           <p:nvPr/>
         </p:nvGraphicFramePr>
         <p:xfrm>
-          <a:off x="1097280" y="1645920"/>
-          <a:ext cx="10058400" cy="4389120"/>
+          <a:off x="1097280" y="1691640"/>
+          <a:ext cx="9997135" cy="4389120"/>
         </p:xfrm>
         <a:graphic>
           <a:graphicData uri="http://schemas.openxmlformats.org/drawingml/2006/table">
@@ -5171,7 +7148,7 @@
               </a:tblPr>
               <a:tblGrid>
                 <a:gridCol w="1280160"/>
-                <a:gridCol w="8778240"/>
+                <a:gridCol w="8716975"/>
               </a:tblGrid>
               <a:tr h="731520">
                 <a:tc>
@@ -5194,7 +7171,7 @@
                   </a:txBody>
                   <a:tcPr>
                     <a:solidFill>
-                      <a:srgbClr val="4682B4"/>
+                      <a:srgbClr val="1A365D"/>
                     </a:solidFill>
                   </a:tcPr>
                 </a:tc>
@@ -5218,7 +7195,7 @@
                   </a:txBody>
                   <a:tcPr>
                     <a:solidFill>
-                      <a:srgbClr val="4682B4"/>
+                      <a:srgbClr val="1A365D"/>
                     </a:solidFill>
                   </a:tcPr>
                 </a:tc>
@@ -5230,9 +7207,9 @@
                     <a:lstStyle/>
                     <a:p>
                       <a:pPr algn="ctr">
-                        <a:defRPr sz="1300">
+                        <a:defRPr sz="1300" b="1">
                           <a:solidFill>
-                            <a:srgbClr val="000000"/>
+                            <a:srgbClr val="1E293B"/>
                           </a:solidFill>
                           <a:latin typeface="Arial"/>
                         </a:defRPr>
@@ -5244,7 +7221,7 @@
                   </a:txBody>
                   <a:tcPr>
                     <a:solidFill>
-                      <a:srgbClr val="E6F0FA"/>
+                      <a:srgbClr val="F8FAFC"/>
                     </a:solidFill>
                   </a:tcPr>
                 </a:tc>
@@ -5256,7 +7233,7 @@
                       <a:pPr>
                         <a:defRPr sz="1300">
                           <a:solidFill>
-                            <a:srgbClr val="000000"/>
+                            <a:srgbClr val="1E293B"/>
                           </a:solidFill>
                           <a:latin typeface="Arial"/>
                         </a:defRPr>
@@ -5268,7 +7245,7 @@
                   </a:txBody>
                   <a:tcPr>
                     <a:solidFill>
-                      <a:srgbClr val="E6F0FA"/>
+                      <a:srgbClr val="F8FAFC"/>
                     </a:solidFill>
                   </a:tcPr>
                 </a:tc>
@@ -5280,9 +7257,9 @@
                     <a:lstStyle/>
                     <a:p>
                       <a:pPr algn="ctr">
-                        <a:defRPr sz="1300">
+                        <a:defRPr sz="1300" b="1">
                           <a:solidFill>
-                            <a:srgbClr val="000000"/>
+                            <a:srgbClr val="1E293B"/>
                           </a:solidFill>
                           <a:latin typeface="Arial"/>
                         </a:defRPr>
@@ -5306,7 +7283,7 @@
                       <a:pPr>
                         <a:defRPr sz="1300">
                           <a:solidFill>
-                            <a:srgbClr val="000000"/>
+                            <a:srgbClr val="1E293B"/>
                           </a:solidFill>
                           <a:latin typeface="Arial"/>
                         </a:defRPr>
@@ -5330,9 +7307,9 @@
                     <a:lstStyle/>
                     <a:p>
                       <a:pPr algn="ctr">
-                        <a:defRPr sz="1300">
+                        <a:defRPr sz="1300" b="1">
                           <a:solidFill>
-                            <a:srgbClr val="000000"/>
+                            <a:srgbClr val="1E293B"/>
                           </a:solidFill>
                           <a:latin typeface="Arial"/>
                         </a:defRPr>
@@ -5344,7 +7321,7 @@
                   </a:txBody>
                   <a:tcPr>
                     <a:solidFill>
-                      <a:srgbClr val="E6F0FA"/>
+                      <a:srgbClr val="F8FAFC"/>
                     </a:solidFill>
                   </a:tcPr>
                 </a:tc>
@@ -5356,7 +7333,7 @@
                       <a:pPr>
                         <a:defRPr sz="1300">
                           <a:solidFill>
-                            <a:srgbClr val="000000"/>
+                            <a:srgbClr val="1E293B"/>
                           </a:solidFill>
                           <a:latin typeface="Arial"/>
                         </a:defRPr>
@@ -5368,7 +7345,7 @@
                   </a:txBody>
                   <a:tcPr>
                     <a:solidFill>
-                      <a:srgbClr val="E6F0FA"/>
+                      <a:srgbClr val="F8FAFC"/>
                     </a:solidFill>
                   </a:tcPr>
                 </a:tc>
@@ -5380,9 +7357,9 @@
                     <a:lstStyle/>
                     <a:p>
                       <a:pPr algn="ctr">
-                        <a:defRPr sz="1300">
+                        <a:defRPr sz="1300" b="1">
                           <a:solidFill>
-                            <a:srgbClr val="000000"/>
+                            <a:srgbClr val="1E293B"/>
                           </a:solidFill>
                           <a:latin typeface="Arial"/>
                         </a:defRPr>
@@ -5406,7 +7383,7 @@
                       <a:pPr>
                         <a:defRPr sz="1300">
                           <a:solidFill>
-                            <a:srgbClr val="000000"/>
+                            <a:srgbClr val="1E293B"/>
                           </a:solidFill>
                           <a:latin typeface="Arial"/>
                         </a:defRPr>
@@ -5430,9 +7407,9 @@
                     <a:lstStyle/>
                     <a:p>
                       <a:pPr algn="ctr">
-                        <a:defRPr sz="1300">
+                        <a:defRPr sz="1300" b="1">
                           <a:solidFill>
-                            <a:srgbClr val="000000"/>
+                            <a:srgbClr val="1E293B"/>
                           </a:solidFill>
                           <a:latin typeface="Arial"/>
                         </a:defRPr>
@@ -5444,7 +7421,7 @@
                   </a:txBody>
                   <a:tcPr>
                     <a:solidFill>
-                      <a:srgbClr val="E6F0FA"/>
+                      <a:srgbClr val="F8FAFC"/>
                     </a:solidFill>
                   </a:tcPr>
                 </a:tc>
@@ -5456,7 +7433,7 @@
                       <a:pPr>
                         <a:defRPr sz="1300">
                           <a:solidFill>
-                            <a:srgbClr val="000000"/>
+                            <a:srgbClr val="1E293B"/>
                           </a:solidFill>
                           <a:latin typeface="Arial"/>
                         </a:defRPr>
@@ -5468,7 +7445,7 @@
                   </a:txBody>
                   <a:tcPr>
                     <a:solidFill>
-                      <a:srgbClr val="E6F0FA"/>
+                      <a:srgbClr val="F8FAFC"/>
                     </a:solidFill>
                   </a:tcPr>
                 </a:tc>

</xml_diff>